<commit_message>
Add 'what it stands for' column to terminal commands
- Add 4th column to README command table explaining what each command abbreviation stands for
- Update phrase cards in index.html with blue .stands-for lines and bolded key letters
- Regenerate README.pptx with updated command table slide
- Enhance CSS to support the new stands-for styling
</commit_message>
<xml_diff>
--- a/pods/01-hello-terminal/README.pptx
+++ b/pods/01-hello-terminal/README.pptx
@@ -9922,9 +9922,10 @@
                 <a:tableStyleId>{5C22544A-7EE6-4342-B048-85BDC9FD1C3A}</a:tableStyleId>
               </a:tblPr>
               <a:tblGrid>
-                <a:gridCol w="3576218"/>
-                <a:gridCol w="3576218"/>
-                <a:gridCol w="3576219"/>
+                <a:gridCol w="2682163"/>
+                <a:gridCol w="2682163"/>
+                <a:gridCol w="2682163"/>
+                <a:gridCol w="2682166"/>
               </a:tblGrid>
               <a:tr h="411480">
                 <a:tc>
@@ -9990,6 +9991,30 @@
                       </a:pPr>
                       <a:r>
                         <a:t>In the terminal</a:t>
+                      </a:r>
+                    </a:p>
+                  </a:txBody>
+                  <a:tcPr>
+                    <a:solidFill>
+                      <a:srgbClr val="1E2C56"/>
+                    </a:solidFill>
+                  </a:tcPr>
+                </a:tc>
+                <a:tc>
+                  <a:txBody>
+                    <a:bodyPr/>
+                    <a:lstStyle/>
+                    <a:p>
+                      <a:pPr>
+                        <a:defRPr sz="1400" b="1">
+                          <a:solidFill>
+                            <a:srgbClr val="FFFFFF"/>
+                          </a:solidFill>
+                          <a:latin typeface="Lato"/>
+                        </a:defRPr>
+                      </a:pPr>
+                      <a:r>
+                        <a:t>What it stands for</a:t>
                       </a:r>
                     </a:p>
                   </a:txBody>
@@ -10073,6 +10098,30 @@
                     </a:solidFill>
                   </a:tcPr>
                 </a:tc>
+                <a:tc>
+                  <a:txBody>
+                    <a:bodyPr/>
+                    <a:lstStyle/>
+                    <a:p>
+                      <a:pPr>
+                        <a:defRPr sz="1200">
+                          <a:solidFill>
+                            <a:srgbClr val="E0E0E0"/>
+                          </a:solidFill>
+                          <a:latin typeface="Lato"/>
+                        </a:defRPr>
+                      </a:pPr>
+                      <a:r>
+                        <a:t>**l**i**s**t</a:t>
+                      </a:r>
+                    </a:p>
+                  </a:txBody>
+                  <a:tcPr>
+                    <a:solidFill>
+                      <a:srgbClr val="16213E"/>
+                    </a:solidFill>
+                  </a:tcPr>
+                </a:tc>
               </a:tr>
               <a:tr h="411480">
                 <a:tc>
@@ -10138,6 +10187,30 @@
                       </a:pPr>
                       <a:r>
                         <a:t>`cd folder-name`</a:t>
+                      </a:r>
+                    </a:p>
+                  </a:txBody>
+                  <a:tcPr>
+                    <a:solidFill>
+                      <a:srgbClr val="1A1A2E"/>
+                    </a:solidFill>
+                  </a:tcPr>
+                </a:tc>
+                <a:tc>
+                  <a:txBody>
+                    <a:bodyPr/>
+                    <a:lstStyle/>
+                    <a:p>
+                      <a:pPr>
+                        <a:defRPr sz="1200">
+                          <a:solidFill>
+                            <a:srgbClr val="E0E0E0"/>
+                          </a:solidFill>
+                          <a:latin typeface="Lato"/>
+                        </a:defRPr>
+                      </a:pPr>
+                      <a:r>
+                        <a:t>**c**hange **d**irectory</a:t>
                       </a:r>
                     </a:p>
                   </a:txBody>
@@ -10221,6 +10294,30 @@
                     </a:solidFill>
                   </a:tcPr>
                 </a:tc>
+                <a:tc>
+                  <a:txBody>
+                    <a:bodyPr/>
+                    <a:lstStyle/>
+                    <a:p>
+                      <a:pPr>
+                        <a:defRPr sz="1200">
+                          <a:solidFill>
+                            <a:srgbClr val="E0E0E0"/>
+                          </a:solidFill>
+                          <a:latin typeface="Lato"/>
+                        </a:defRPr>
+                      </a:pPr>
+                      <a:r>
+                        <a:t>**p**rint **w**orking **d**irectory</a:t>
+                      </a:r>
+                    </a:p>
+                  </a:txBody>
+                  <a:tcPr>
+                    <a:solidFill>
+                      <a:srgbClr val="16213E"/>
+                    </a:solidFill>
+                  </a:tcPr>
+                </a:tc>
               </a:tr>
               <a:tr h="411480">
                 <a:tc>
@@ -10295,6 +10392,30 @@
                     </a:solidFill>
                   </a:tcPr>
                 </a:tc>
+                <a:tc>
+                  <a:txBody>
+                    <a:bodyPr/>
+                    <a:lstStyle/>
+                    <a:p>
+                      <a:pPr>
+                        <a:defRPr sz="1200">
+                          <a:solidFill>
+                            <a:srgbClr val="E0E0E0"/>
+                          </a:solidFill>
+                          <a:latin typeface="Lato"/>
+                        </a:defRPr>
+                      </a:pPr>
+                      <a:r>
+                        <a:t>**m**a**k**e **dir**ectory</a:t>
+                      </a:r>
+                    </a:p>
+                  </a:txBody>
+                  <a:tcPr>
+                    <a:solidFill>
+                      <a:srgbClr val="1A1A2E"/>
+                    </a:solidFill>
+                  </a:tcPr>
+                </a:tc>
               </a:tr>
               <a:tr h="411480">
                 <a:tc>
@@ -10360,6 +10481,30 @@
                       </a:pPr>
                       <a:r>
                         <a:t>`cd ..`</a:t>
+                      </a:r>
+                    </a:p>
+                  </a:txBody>
+                  <a:tcPr>
+                    <a:solidFill>
+                      <a:srgbClr val="16213E"/>
+                    </a:solidFill>
+                  </a:tcPr>
+                </a:tc>
+                <a:tc>
+                  <a:txBody>
+                    <a:bodyPr/>
+                    <a:lstStyle/>
+                    <a:p>
+                      <a:pPr>
+                        <a:defRPr sz="1200">
+                          <a:solidFill>
+                            <a:srgbClr val="E0E0E0"/>
+                          </a:solidFill>
+                          <a:latin typeface="Lato"/>
+                        </a:defRPr>
+                      </a:pPr>
+                      <a:r>
+                        <a:t>**c**hange **d**irectory to parent</a:t>
                       </a:r>
                     </a:p>
                   </a:txBody>

</xml_diff>

<commit_message>
Update Pod 01 with SSH auth, folder structure motivation, and clone slides
- Add 'Why This Structure Matters for AI' and 'Your Folder is Claude's Context' slides to motivate folder organization
- Replace HTTPS GitHub auth with SSH workflow including 'What is SSH?' plain-English explanation
- Add detailed git clone steps with exact Claude prompts and 'What Was Just Downloaded?' slide
- Add 'Proof of Completion' slide tied to launching index.html
- Regenerate README.pptx with manual edits applied

Co-Authored-By: Claude Sonnet 4.6 (1M context) <noreply@anthropic.com>
</commit_message>
<xml_diff>
--- a/pods/01-hello-terminal/README.pptx
+++ b/pods/01-hello-terminal/README.pptx
@@ -46,6 +46,10 @@
     <p:sldId id="294" r:id="rId45"/>
     <p:sldId id="295" r:id="rId46"/>
     <p:sldId id="296" r:id="rId47"/>
+    <p:sldId id="297" r:id="rId48"/>
+    <p:sldId id="298" r:id="rId49"/>
+    <p:sldId id="299" r:id="rId50"/>
+    <p:sldId id="300" r:id="rId51"/>
   </p:sldIdLst>
   <p:sldSz cx="12191695" cy="6858000" type="screen4x3"/>
   <p:notesSz cx="6858000" cy="9144000"/>
@@ -3833,8 +3837,8 @@
         </p:nvSpPr>
         <p:spPr>
           <a:xfrm>
-            <a:off x="914400" y="2560320"/>
-            <a:ext cx="10362895" cy="1371600"/>
+            <a:off x="731520" y="365760"/>
+            <a:ext cx="10728655" cy="914400"/>
           </a:xfrm>
           <a:prstGeom prst="rect">
             <a:avLst/>
@@ -3842,20 +3846,18 @@
           <a:noFill/>
         </p:spPr>
         <p:txBody>
-          <a:bodyPr wrap="square">
-            <a:spAutoFit/>
-          </a:bodyPr>
-          <a:lstStyle/>
-          <a:p>
-            <a:pPr algn="ctr"/>
-            <a:r>
-              <a:rPr sz="3200" b="1" i="0">
+          <a:bodyPr wrap="square"/>
+          <a:lstStyle/>
+          <a:p>
+            <a:pPr algn="l"/>
+            <a:r>
+              <a:rPr sz="2800" b="1" i="0">
                 <a:solidFill>
                   <a:srgbClr val="FFFFFF"/>
                 </a:solidFill>
                 <a:latin typeface="Lato"/>
               </a:rPr>
-              <a:t>Your First Project</a:t>
+              <a:t>Why This Structure Matters for AI</a:t>
             </a:r>
           </a:p>
         </p:txBody>
@@ -3868,8 +3870,8 @@
         </p:nvSpPr>
         <p:spPr>
           <a:xfrm>
-            <a:off x="4724247" y="4114800"/>
-            <a:ext cx="2743200" cy="54864"/>
+            <a:off x="5181447" y="1325880"/>
+            <a:ext cx="1828800" cy="54864"/>
           </a:xfrm>
           <a:prstGeom prst="rect">
             <a:avLst/>
@@ -3900,6 +3902,107 @@
           <a:lstStyle/>
           <a:p>
             <a:pPr algn="ctr"/>
+          </a:p>
+        </p:txBody>
+      </p:sp>
+      <p:sp>
+        <p:nvSpPr>
+          <p:cNvPr id="4" name="TextBox 3"/>
+          <p:cNvSpPr txBox="1"/>
+          <p:nvPr/>
+        </p:nvSpPr>
+        <p:spPr>
+          <a:xfrm>
+            <a:off x="731520" y="1645920"/>
+            <a:ext cx="10728655" cy="4754880"/>
+          </a:xfrm>
+          <a:prstGeom prst="rect">
+            <a:avLst/>
+          </a:prstGeom>
+          <a:noFill/>
+        </p:spPr>
+        <p:txBody>
+          <a:bodyPr wrap="square"/>
+          <a:lstStyle/>
+          <a:p>
+            <a:pPr algn="l">
+              <a:spcAft>
+                <a:spcPts val="1000"/>
+              </a:spcAft>
+            </a:pPr>
+            <a:r>
+              <a:rPr sz="1800" b="0" i="0">
+                <a:solidFill>
+                  <a:srgbClr val="E0E0E0"/>
+                </a:solidFill>
+                <a:latin typeface="Lato"/>
+              </a:rPr>
+              <a:t>•  Claude reads your project folder to understand what you're building</a:t>
+            </a:r>
+          </a:p>
+          <a:p>
+            <a:pPr algn="l">
+              <a:spcAft>
+                <a:spcPts val="1000"/>
+              </a:spcAft>
+            </a:pPr>
+            <a:r>
+              <a:rPr sz="1800" b="0" i="0">
+                <a:solidFill>
+                  <a:srgbClr val="E0E0E0"/>
+                </a:solidFill>
+                <a:latin typeface="Lato"/>
+              </a:rPr>
+              <a:t>•  One folder = one project = one clear briefing for Claude</a:t>
+            </a:r>
+          </a:p>
+          <a:p>
+            <a:pPr algn="l">
+              <a:spcAft>
+                <a:spcPts val="1000"/>
+              </a:spcAft>
+            </a:pPr>
+            <a:r>
+              <a:rPr sz="1800" b="0" i="0">
+                <a:solidFill>
+                  <a:srgbClr val="E0E0E0"/>
+                </a:solidFill>
+                <a:latin typeface="Lato"/>
+              </a:rPr>
+              <a:t>•  Scattered files on your Desktop = Claude guessing what belongs together</a:t>
+            </a:r>
+          </a:p>
+          <a:p>
+            <a:pPr algn="l">
+              <a:spcAft>
+                <a:spcPts val="1000"/>
+              </a:spcAft>
+            </a:pPr>
+            <a:r>
+              <a:rPr sz="1800" b="0" i="0">
+                <a:solidFill>
+                  <a:srgbClr val="E0E0E0"/>
+                </a:solidFill>
+                <a:latin typeface="Lato"/>
+              </a:rPr>
+              <a:t>•  Clean structure → faster, more accurate results every time</a:t>
+            </a:r>
+          </a:p>
+          <a:p>
+            <a:pPr algn="l">
+              <a:spcAft>
+                <a:spcPts val="1000"/>
+              </a:spcAft>
+            </a:pPr>
+            <a:r>
+              <a:rPr sz="1800" b="0" i="0">
+                <a:solidFill>
+                  <a:srgbClr val="E0E0E0"/>
+                </a:solidFill>
+                <a:latin typeface="Lato"/>
+              </a:rPr>
+              <a:t>•  Coming in Pod 02: a CLAUDE.md file in each project — a note that tells Claude the rules and context for that project</a:t>
+            </a:r>
           </a:p>
         </p:txBody>
       </p:sp>
@@ -3957,29 +4060,27 @@
                 </a:solidFill>
                 <a:latin typeface="Lato"/>
               </a:rPr>
-              <a:t>Let's Build Something</a:t>
-            </a:r>
-          </a:p>
-        </p:txBody>
-      </p:sp>
-      <p:sp>
-        <p:nvSpPr>
-          <p:cNvPr id="3" name="Rounded Rectangle 2"/>
+              <a:t>Your Folder is Claude's Context</a:t>
+            </a:r>
+          </a:p>
+        </p:txBody>
+      </p:sp>
+      <p:sp>
+        <p:nvSpPr>
+          <p:cNvPr id="3" name="Rectangle 2"/>
           <p:cNvSpPr/>
           <p:nvPr/>
         </p:nvSpPr>
         <p:spPr>
           <a:xfrm>
-            <a:off x="640080" y="1463040"/>
-            <a:ext cx="10911535" cy="4937760"/>
-          </a:xfrm>
-          <a:prstGeom prst="roundRect">
-            <a:avLst>
-              <a:gd name="adj" fmla="val 2000"/>
-            </a:avLst>
+            <a:off x="5181447" y="1325880"/>
+            <a:ext cx="1828800" cy="54864"/>
+          </a:xfrm>
+          <a:prstGeom prst="rect">
+            <a:avLst/>
           </a:prstGeom>
           <a:solidFill>
-            <a:srgbClr val="16213E"/>
+            <a:srgbClr val="4A90D9"/>
           </a:solidFill>
           <a:ln>
             <a:noFill/>
@@ -4015,8 +4116,8 @@
         </p:nvSpPr>
         <p:spPr>
           <a:xfrm>
-            <a:off x="914400" y="1645920"/>
-            <a:ext cx="10545775" cy="4572000"/>
+            <a:off x="731520" y="1645920"/>
+            <a:ext cx="10728655" cy="4754880"/>
           </a:xfrm>
           <a:prstGeom prst="rect">
             <a:avLst/>
@@ -4027,51 +4128,83 @@
           <a:bodyPr wrap="square"/>
           <a:lstStyle/>
           <a:p>
-            <a:pPr>
+            <a:pPr algn="l">
               <a:spcAft>
-                <a:spcPts val="200"/>
+                <a:spcPts val="1000"/>
               </a:spcAft>
             </a:pPr>
             <a:r>
-              <a:rPr sz="1400" b="0" i="0">
+              <a:rPr sz="1800" b="0" i="0">
                 <a:solidFill>
                   <a:srgbClr val="E0E0E0"/>
                 </a:solidFill>
-                <a:latin typeface="Consolas"/>
-              </a:rPr>
-              <a:t>   mkdir ~/claude_projects</a:t>
-            </a:r>
-          </a:p>
-          <a:p>
-            <a:pPr>
+                <a:latin typeface="Lato"/>
+              </a:rPr>
+              <a:t>•  When you type `claude` inside a folder, Claude scans everything inside it</a:t>
+            </a:r>
+          </a:p>
+          <a:p>
+            <a:pPr algn="l">
               <a:spcAft>
-                <a:spcPts val="200"/>
+                <a:spcPts val="1000"/>
               </a:spcAft>
             </a:pPr>
             <a:r>
-              <a:rPr sz="1400" b="0" i="0">
+              <a:rPr sz="1800" b="0" i="0">
                 <a:solidFill>
                   <a:srgbClr val="E0E0E0"/>
                 </a:solidFill>
-                <a:latin typeface="Consolas"/>
-              </a:rPr>
-              <a:t>   mkdir ~/claude_projects/my-first-project</a:t>
-            </a:r>
-          </a:p>
-          <a:p>
-            <a:pPr>
+                <a:latin typeface="Lato"/>
+              </a:rPr>
+              <a:t>•  It sees your files, your work-in-progress, and any instructions you've left</a:t>
+            </a:r>
+          </a:p>
+          <a:p>
+            <a:pPr algn="l">
               <a:spcAft>
-                <a:spcPts val="200"/>
+                <a:spcPts val="1000"/>
               </a:spcAft>
             </a:pPr>
             <a:r>
-              <a:rPr sz="1400" b="0" i="0">
+              <a:rPr sz="1800" b="0" i="0">
                 <a:solidFill>
                   <a:srgbClr val="E0E0E0"/>
                 </a:solidFill>
-                <a:latin typeface="Consolas"/>
-              </a:rPr>
-              <a:t>   cd ~/claude_projects/my-first-project</a:t>
+                <a:latin typeface="Lato"/>
+              </a:rPr>
+              <a:t>•  `~/claude_projects/client-dashboard/` tells Claude: these files are one project, work here</a:t>
+            </a:r>
+          </a:p>
+          <a:p>
+            <a:pPr algn="l">
+              <a:spcAft>
+                <a:spcPts val="1000"/>
+              </a:spcAft>
+            </a:pPr>
+            <a:r>
+              <a:rPr sz="1800" b="0" i="0">
+                <a:solidFill>
+                  <a:srgbClr val="E0E0E0"/>
+                </a:solidFill>
+                <a:latin typeface="Lato"/>
+              </a:rPr>
+              <a:t>•  A well-named, well-organized folder = a well-briefed AI assistant</a:t>
+            </a:r>
+          </a:p>
+          <a:p>
+            <a:pPr algn="l">
+              <a:spcAft>
+                <a:spcPts val="1000"/>
+              </a:spcAft>
+            </a:pPr>
+            <a:r>
+              <a:rPr sz="1800" b="0" i="0">
+                <a:solidFill>
+                  <a:srgbClr val="E0E0E0"/>
+                </a:solidFill>
+                <a:latin typeface="Lato"/>
+              </a:rPr>
+              <a:t>•  Think of it like handing a consultant a labeled binder vs. a pile of loose pages on a desk</a:t>
             </a:r>
           </a:p>
         </p:txBody>
@@ -4110,8 +4243,8 @@
         </p:nvSpPr>
         <p:spPr>
           <a:xfrm>
-            <a:off x="731520" y="365760"/>
-            <a:ext cx="10728655" cy="914400"/>
+            <a:off x="914400" y="2560320"/>
+            <a:ext cx="10362895" cy="1371600"/>
           </a:xfrm>
           <a:prstGeom prst="rect">
             <a:avLst/>
@@ -4119,40 +4252,40 @@
           <a:noFill/>
         </p:spPr>
         <p:txBody>
-          <a:bodyPr wrap="square"/>
-          <a:lstStyle/>
-          <a:p>
-            <a:pPr algn="l"/>
-            <a:r>
-              <a:rPr sz="2800" b="1" i="0">
+          <a:bodyPr wrap="square">
+            <a:spAutoFit/>
+          </a:bodyPr>
+          <a:lstStyle/>
+          <a:p>
+            <a:pPr algn="ctr"/>
+            <a:r>
+              <a:rPr sz="3200" b="1" i="0">
                 <a:solidFill>
                   <a:srgbClr val="FFFFFF"/>
                 </a:solidFill>
                 <a:latin typeface="Lato"/>
               </a:rPr>
-              <a:t>Let's Build Something</a:t>
-            </a:r>
-          </a:p>
-        </p:txBody>
-      </p:sp>
-      <p:sp>
-        <p:nvSpPr>
-          <p:cNvPr id="3" name="Rounded Rectangle 2"/>
+              <a:t>Your First Project</a:t>
+            </a:r>
+          </a:p>
+        </p:txBody>
+      </p:sp>
+      <p:sp>
+        <p:nvSpPr>
+          <p:cNvPr id="3" name="Rectangle 2"/>
           <p:cNvSpPr/>
           <p:nvPr/>
         </p:nvSpPr>
         <p:spPr>
           <a:xfrm>
-            <a:off x="640080" y="1463040"/>
-            <a:ext cx="10911535" cy="4937760"/>
-          </a:xfrm>
-          <a:prstGeom prst="roundRect">
-            <a:avLst>
-              <a:gd name="adj" fmla="val 2000"/>
-            </a:avLst>
+            <a:off x="4724247" y="4114800"/>
+            <a:ext cx="2743200" cy="54864"/>
+          </a:xfrm>
+          <a:prstGeom prst="rect">
+            <a:avLst/>
           </a:prstGeom>
           <a:solidFill>
-            <a:srgbClr val="16213E"/>
+            <a:srgbClr val="4A90D9"/>
           </a:solidFill>
           <a:ln>
             <a:noFill/>
@@ -4177,113 +4310,6 @@
           <a:lstStyle/>
           <a:p>
             <a:pPr algn="ctr"/>
-          </a:p>
-        </p:txBody>
-      </p:sp>
-      <p:sp>
-        <p:nvSpPr>
-          <p:cNvPr id="4" name="TextBox 3"/>
-          <p:cNvSpPr txBox="1"/>
-          <p:nvPr/>
-        </p:nvSpPr>
-        <p:spPr>
-          <a:xfrm>
-            <a:off x="914400" y="1645920"/>
-            <a:ext cx="10545775" cy="4572000"/>
-          </a:xfrm>
-          <a:prstGeom prst="rect">
-            <a:avLst/>
-          </a:prstGeom>
-          <a:noFill/>
-        </p:spPr>
-        <p:txBody>
-          <a:bodyPr wrap="square"/>
-          <a:lstStyle/>
-          <a:p>
-            <a:pPr>
-              <a:spcAft>
-                <a:spcPts val="200"/>
-              </a:spcAft>
-            </a:pPr>
-            <a:r>
-              <a:rPr sz="1400" b="0" i="0">
-                <a:solidFill>
-                  <a:srgbClr val="E0E0E0"/>
-                </a:solidFill>
-                <a:latin typeface="Consolas"/>
-              </a:rPr>
-              <a:t>   claude</a:t>
-            </a:r>
-          </a:p>
-        </p:txBody>
-      </p:sp>
-      <p:sp>
-        <p:nvSpPr>
-          <p:cNvPr id="5" name="TextBox 4"/>
-          <p:cNvSpPr txBox="1"/>
-          <p:nvPr/>
-        </p:nvSpPr>
-        <p:spPr>
-          <a:xfrm>
-            <a:off x="1005840" y="5669280"/>
-            <a:ext cx="10180015" cy="640080"/>
-          </a:xfrm>
-          <a:prstGeom prst="rect">
-            <a:avLst/>
-          </a:prstGeom>
-          <a:noFill/>
-        </p:spPr>
-        <p:txBody>
-          <a:bodyPr wrap="square">
-            <a:spAutoFit/>
-          </a:bodyPr>
-          <a:lstStyle/>
-          <a:p>
-            <a:pPr algn="l"/>
-            <a:r>
-              <a:rPr sz="1600" b="0" i="1">
-                <a:solidFill>
-                  <a:srgbClr val="4A90D9"/>
-                </a:solidFill>
-                <a:latin typeface="Lato"/>
-              </a:rPr>
-              <a:t>“Create an HTML page that says Hello [your name] with a dark background and today's date. Make it look professional.”</a:t>
-            </a:r>
-          </a:p>
-        </p:txBody>
-      </p:sp>
-      <p:sp>
-        <p:nvSpPr>
-          <p:cNvPr id="6" name="TextBox 5"/>
-          <p:cNvSpPr txBox="1"/>
-          <p:nvPr/>
-        </p:nvSpPr>
-        <p:spPr>
-          <a:xfrm>
-            <a:off x="1005840" y="5669280"/>
-            <a:ext cx="10180015" cy="640080"/>
-          </a:xfrm>
-          <a:prstGeom prst="rect">
-            <a:avLst/>
-          </a:prstGeom>
-          <a:noFill/>
-        </p:spPr>
-        <p:txBody>
-          <a:bodyPr wrap="square">
-            <a:spAutoFit/>
-          </a:bodyPr>
-          <a:lstStyle/>
-          <a:p>
-            <a:pPr algn="l"/>
-            <a:r>
-              <a:rPr sz="1600" b="0" i="1">
-                <a:solidFill>
-                  <a:srgbClr val="4A90D9"/>
-                </a:solidFill>
-                <a:latin typeface="Lato"/>
-              </a:rPr>
-              <a:t>“Add a section about what I do at Oren and change the background to a dark blue (#1a1a2e)”</a:t>
-            </a:r>
           </a:p>
         </p:txBody>
       </p:sp>
@@ -4348,20 +4374,22 @@
       </p:sp>
       <p:sp>
         <p:nvSpPr>
-          <p:cNvPr id="3" name="Rectangle 2"/>
+          <p:cNvPr id="3" name="Rounded Rectangle 2"/>
           <p:cNvSpPr/>
           <p:nvPr/>
         </p:nvSpPr>
         <p:spPr>
           <a:xfrm>
-            <a:off x="5181447" y="1325880"/>
-            <a:ext cx="1828800" cy="54864"/>
-          </a:xfrm>
-          <a:prstGeom prst="rect">
-            <a:avLst/>
+            <a:off x="640080" y="1463040"/>
+            <a:ext cx="10911535" cy="4937760"/>
+          </a:xfrm>
+          <a:prstGeom prst="roundRect">
+            <a:avLst>
+              <a:gd name="adj" fmla="val 2000"/>
+            </a:avLst>
           </a:prstGeom>
           <a:solidFill>
-            <a:srgbClr val="4A90D9"/>
+            <a:srgbClr val="16213E"/>
           </a:solidFill>
           <a:ln>
             <a:noFill/>
@@ -4397,8 +4425,8 @@
         </p:nvSpPr>
         <p:spPr>
           <a:xfrm>
-            <a:off x="731520" y="1645920"/>
-            <a:ext cx="10728655" cy="4754880"/>
+            <a:off x="914400" y="1645920"/>
+            <a:ext cx="10545775" cy="4572000"/>
           </a:xfrm>
           <a:prstGeom prst="rect">
             <a:avLst/>
@@ -4409,153 +4437,51 @@
           <a:bodyPr wrap="square"/>
           <a:lstStyle/>
           <a:p>
-            <a:pPr algn="l">
+            <a:pPr>
               <a:spcAft>
-                <a:spcPts val="1200"/>
+                <a:spcPts val="200"/>
               </a:spcAft>
             </a:pPr>
             <a:r>
-              <a:rPr sz="1800" b="1" i="0">
-                <a:solidFill>
-                  <a:srgbClr val="4A90D9"/>
-                </a:solidFill>
-                <a:latin typeface="Lato"/>
-              </a:rPr>
-              <a:t>1.  </a:t>
-            </a:r>
-            <a:r>
-              <a:rPr sz="1800" b="0" i="0">
+              <a:rPr sz="1400" b="0" i="0">
                 <a:solidFill>
                   <a:srgbClr val="E0E0E0"/>
                 </a:solidFill>
-                <a:latin typeface="Lato"/>
-              </a:rPr>
-              <a:t>Create your home base and first project folder:</a:t>
-            </a:r>
-          </a:p>
-          <a:p>
-            <a:pPr algn="l">
+                <a:latin typeface="Consolas"/>
+              </a:rPr>
+              <a:t>   mkdir ~/claude_projects</a:t>
+            </a:r>
+          </a:p>
+          <a:p>
+            <a:pPr>
               <a:spcAft>
-                <a:spcPts val="1200"/>
+                <a:spcPts val="200"/>
               </a:spcAft>
             </a:pPr>
             <a:r>
-              <a:rPr sz="1800" b="1" i="0">
-                <a:solidFill>
-                  <a:srgbClr val="4A90D9"/>
-                </a:solidFill>
-                <a:latin typeface="Lato"/>
-              </a:rPr>
-              <a:t>2.  </a:t>
-            </a:r>
-            <a:r>
-              <a:rPr sz="1800" b="0" i="0">
+              <a:rPr sz="1400" b="0" i="0">
                 <a:solidFill>
                   <a:srgbClr val="E0E0E0"/>
                 </a:solidFill>
-                <a:latin typeface="Lato"/>
-              </a:rPr>
-              <a:t>Start Claude Code:</a:t>
-            </a:r>
-          </a:p>
-          <a:p>
-            <a:pPr algn="l">
+                <a:latin typeface="Consolas"/>
+              </a:rPr>
+              <a:t>   mkdir ~/claude_projects/my-first-project</a:t>
+            </a:r>
+          </a:p>
+          <a:p>
+            <a:pPr>
               <a:spcAft>
-                <a:spcPts val="1200"/>
+                <a:spcPts val="200"/>
               </a:spcAft>
             </a:pPr>
             <a:r>
-              <a:rPr sz="1800" b="1" i="0">
-                <a:solidFill>
-                  <a:srgbClr val="4A90D9"/>
-                </a:solidFill>
-                <a:latin typeface="Lato"/>
-              </a:rPr>
-              <a:t>3.  </a:t>
-            </a:r>
-            <a:r>
-              <a:rPr sz="1800" b="0" i="0">
+              <a:rPr sz="1400" b="0" i="0">
                 <a:solidFill>
                   <a:srgbClr val="E0E0E0"/>
                 </a:solidFill>
-                <a:latin typeface="Lato"/>
-              </a:rPr>
-              <a:t>Type a prompt — your first instruction to Claude:</a:t>
-            </a:r>
-          </a:p>
-          <a:p>
-            <a:pPr algn="l">
-              <a:spcAft>
-                <a:spcPts val="1200"/>
-              </a:spcAft>
-            </a:pPr>
-            <a:r>
-              <a:rPr sz="1800" b="1" i="0">
-                <a:solidFill>
-                  <a:srgbClr val="4A90D9"/>
-                </a:solidFill>
-                <a:latin typeface="Lato"/>
-              </a:rPr>
-              <a:t>4.  </a:t>
-            </a:r>
-            <a:r>
-              <a:rPr sz="1800" b="0" i="0">
-                <a:solidFill>
-                  <a:srgbClr val="E0E0E0"/>
-                </a:solidFill>
-                <a:latin typeface="Lato"/>
-              </a:rPr>
-              <a:t>Claude will create a file. Open it in your browser — **you just built a webpage without writing a line of code.**</a:t>
-            </a:r>
-          </a:p>
-          <a:p>
-            <a:pPr algn="l">
-              <a:spcAft>
-                <a:spcPts val="1200"/>
-              </a:spcAft>
-            </a:pPr>
-            <a:r>
-              <a:rPr sz="1800" b="1" i="0">
-                <a:solidFill>
-                  <a:srgbClr val="4A90D9"/>
-                </a:solidFill>
-                <a:latin typeface="Lato"/>
-              </a:rPr>
-              <a:t>5.  </a:t>
-            </a:r>
-            <a:r>
-              <a:rPr sz="1800" b="0" i="0">
-                <a:solidFill>
-                  <a:srgbClr val="E0E0E0"/>
-                </a:solidFill>
-                <a:latin typeface="Lato"/>
-              </a:rPr>
-              <a:t>Now iterate — tell Claude:</a:t>
-            </a:r>
-          </a:p>
-          <a:p>
-            <a:pPr algn="l">
-              <a:spcAft>
-                <a:spcPts val="1200"/>
-              </a:spcAft>
-            </a:pPr>
-            <a:r>
-              <a:rPr sz="1800" b="1" i="0">
-                <a:solidFill>
-                  <a:srgbClr val="4A90D9"/>
-                </a:solidFill>
-                <a:latin typeface="Lato"/>
-              </a:rPr>
-              <a:t>6.  </a:t>
-            </a:r>
-            <a:r>
-              <a:rPr sz="1800" b="0" i="0">
-                <a:solidFill>
-                  <a:srgbClr val="E0E0E0"/>
-                </a:solidFill>
-                <a:latin typeface="Lato"/>
-              </a:rPr>
-              <a:t>Refresh your browser. See the changes. **This describe-and-build loop is how you'll work from now on.**</a:t>
+                <a:latin typeface="Consolas"/>
+              </a:rPr>
+              <a:t>   cd ~/claude_projects/my-first-project</a:t>
             </a:r>
           </a:p>
         </p:txBody>
@@ -4594,8 +4520,8 @@
         </p:nvSpPr>
         <p:spPr>
           <a:xfrm>
-            <a:off x="914400" y="2560320"/>
-            <a:ext cx="10362895" cy="1371600"/>
+            <a:off x="731520" y="365760"/>
+            <a:ext cx="10728655" cy="914400"/>
           </a:xfrm>
           <a:prstGeom prst="rect">
             <a:avLst/>
@@ -4603,40 +4529,40 @@
           <a:noFill/>
         </p:spPr>
         <p:txBody>
-          <a:bodyPr wrap="square">
-            <a:spAutoFit/>
-          </a:bodyPr>
-          <a:lstStyle/>
-          <a:p>
-            <a:pPr algn="ctr"/>
-            <a:r>
-              <a:rPr sz="3200" b="1" i="0">
+          <a:bodyPr wrap="square"/>
+          <a:lstStyle/>
+          <a:p>
+            <a:pPr algn="l"/>
+            <a:r>
+              <a:rPr sz="2800" b="1" i="0">
                 <a:solidFill>
                   <a:srgbClr val="FFFFFF"/>
                 </a:solidFill>
                 <a:latin typeface="Lato"/>
               </a:rPr>
-              <a:t>Ctrl+C — Your Emergency Brake</a:t>
-            </a:r>
-          </a:p>
-        </p:txBody>
-      </p:sp>
-      <p:sp>
-        <p:nvSpPr>
-          <p:cNvPr id="3" name="Rectangle 2"/>
+              <a:t>Let's Build Something</a:t>
+            </a:r>
+          </a:p>
+        </p:txBody>
+      </p:sp>
+      <p:sp>
+        <p:nvSpPr>
+          <p:cNvPr id="3" name="Rounded Rectangle 2"/>
           <p:cNvSpPr/>
           <p:nvPr/>
         </p:nvSpPr>
         <p:spPr>
           <a:xfrm>
-            <a:off x="4724247" y="4114800"/>
-            <a:ext cx="2743200" cy="54864"/>
-          </a:xfrm>
-          <a:prstGeom prst="rect">
-            <a:avLst/>
+            <a:off x="640080" y="1463040"/>
+            <a:ext cx="10911535" cy="4937760"/>
+          </a:xfrm>
+          <a:prstGeom prst="roundRect">
+            <a:avLst>
+              <a:gd name="adj" fmla="val 2000"/>
+            </a:avLst>
           </a:prstGeom>
           <a:solidFill>
-            <a:srgbClr val="4A90D9"/>
+            <a:srgbClr val="16213E"/>
           </a:solidFill>
           <a:ln>
             <a:noFill/>
@@ -4661,6 +4587,113 @@
           <a:lstStyle/>
           <a:p>
             <a:pPr algn="ctr"/>
+          </a:p>
+        </p:txBody>
+      </p:sp>
+      <p:sp>
+        <p:nvSpPr>
+          <p:cNvPr id="4" name="TextBox 3"/>
+          <p:cNvSpPr txBox="1"/>
+          <p:nvPr/>
+        </p:nvSpPr>
+        <p:spPr>
+          <a:xfrm>
+            <a:off x="914400" y="1645920"/>
+            <a:ext cx="10545775" cy="4572000"/>
+          </a:xfrm>
+          <a:prstGeom prst="rect">
+            <a:avLst/>
+          </a:prstGeom>
+          <a:noFill/>
+        </p:spPr>
+        <p:txBody>
+          <a:bodyPr wrap="square"/>
+          <a:lstStyle/>
+          <a:p>
+            <a:pPr>
+              <a:spcAft>
+                <a:spcPts val="200"/>
+              </a:spcAft>
+            </a:pPr>
+            <a:r>
+              <a:rPr sz="1400" b="0" i="0">
+                <a:solidFill>
+                  <a:srgbClr val="E0E0E0"/>
+                </a:solidFill>
+                <a:latin typeface="Consolas"/>
+              </a:rPr>
+              <a:t>   claude</a:t>
+            </a:r>
+          </a:p>
+        </p:txBody>
+      </p:sp>
+      <p:sp>
+        <p:nvSpPr>
+          <p:cNvPr id="5" name="TextBox 4"/>
+          <p:cNvSpPr txBox="1"/>
+          <p:nvPr/>
+        </p:nvSpPr>
+        <p:spPr>
+          <a:xfrm>
+            <a:off x="1005840" y="5669280"/>
+            <a:ext cx="10180015" cy="640080"/>
+          </a:xfrm>
+          <a:prstGeom prst="rect">
+            <a:avLst/>
+          </a:prstGeom>
+          <a:noFill/>
+        </p:spPr>
+        <p:txBody>
+          <a:bodyPr wrap="square">
+            <a:spAutoFit/>
+          </a:bodyPr>
+          <a:lstStyle/>
+          <a:p>
+            <a:pPr algn="l"/>
+            <a:r>
+              <a:rPr sz="1600" b="0" i="1">
+                <a:solidFill>
+                  <a:srgbClr val="4A90D9"/>
+                </a:solidFill>
+                <a:latin typeface="Lato"/>
+              </a:rPr>
+              <a:t>“Create an HTML page that says Hello [your name] with a dark background and today's date. Make it look professional.”</a:t>
+            </a:r>
+          </a:p>
+        </p:txBody>
+      </p:sp>
+      <p:sp>
+        <p:nvSpPr>
+          <p:cNvPr id="6" name="TextBox 5"/>
+          <p:cNvSpPr txBox="1"/>
+          <p:nvPr/>
+        </p:nvSpPr>
+        <p:spPr>
+          <a:xfrm>
+            <a:off x="1005840" y="5669280"/>
+            <a:ext cx="10180015" cy="640080"/>
+          </a:xfrm>
+          <a:prstGeom prst="rect">
+            <a:avLst/>
+          </a:prstGeom>
+          <a:noFill/>
+        </p:spPr>
+        <p:txBody>
+          <a:bodyPr wrap="square">
+            <a:spAutoFit/>
+          </a:bodyPr>
+          <a:lstStyle/>
+          <a:p>
+            <a:pPr algn="l"/>
+            <a:r>
+              <a:rPr sz="1600" b="0" i="1">
+                <a:solidFill>
+                  <a:srgbClr val="4A90D9"/>
+                </a:solidFill>
+                <a:latin typeface="Lato"/>
+              </a:rPr>
+              <a:t>“Add a section about what I do at Oren and change the background to a dark blue (#1a1a2e)”</a:t>
+            </a:r>
           </a:p>
         </p:txBody>
       </p:sp>
@@ -4698,8 +4731,8 @@
         </p:nvSpPr>
         <p:spPr>
           <a:xfrm>
-            <a:off x="914400" y="2560320"/>
-            <a:ext cx="10362895" cy="1371600"/>
+            <a:off x="731520" y="365760"/>
+            <a:ext cx="10728655" cy="914400"/>
           </a:xfrm>
           <a:prstGeom prst="rect">
             <a:avLst/>
@@ -4707,20 +4740,18 @@
           <a:noFill/>
         </p:spPr>
         <p:txBody>
-          <a:bodyPr wrap="square">
-            <a:spAutoFit/>
-          </a:bodyPr>
-          <a:lstStyle/>
-          <a:p>
-            <a:pPr algn="ctr"/>
-            <a:r>
-              <a:rPr sz="3200" b="1" i="0">
+          <a:bodyPr wrap="square"/>
+          <a:lstStyle/>
+          <a:p>
+            <a:pPr algn="l"/>
+            <a:r>
+              <a:rPr sz="2800" b="1" i="0">
                 <a:solidFill>
                   <a:srgbClr val="FFFFFF"/>
                 </a:solidFill>
                 <a:latin typeface="Lato"/>
               </a:rPr>
-              <a:t>Why Git and GitHub?</a:t>
+              <a:t>Let's Build Something</a:t>
             </a:r>
           </a:p>
         </p:txBody>
@@ -4733,8 +4764,8 @@
         </p:nvSpPr>
         <p:spPr>
           <a:xfrm>
-            <a:off x="4724247" y="4114800"/>
-            <a:ext cx="2743200" cy="54864"/>
+            <a:off x="5181447" y="1325880"/>
+            <a:ext cx="1828800" cy="54864"/>
           </a:xfrm>
           <a:prstGeom prst="rect">
             <a:avLst/>
@@ -4765,6 +4796,177 @@
           <a:lstStyle/>
           <a:p>
             <a:pPr algn="ctr"/>
+          </a:p>
+        </p:txBody>
+      </p:sp>
+      <p:sp>
+        <p:nvSpPr>
+          <p:cNvPr id="4" name="TextBox 3"/>
+          <p:cNvSpPr txBox="1"/>
+          <p:nvPr/>
+        </p:nvSpPr>
+        <p:spPr>
+          <a:xfrm>
+            <a:off x="731520" y="1645920"/>
+            <a:ext cx="10728655" cy="4754880"/>
+          </a:xfrm>
+          <a:prstGeom prst="rect">
+            <a:avLst/>
+          </a:prstGeom>
+          <a:noFill/>
+        </p:spPr>
+        <p:txBody>
+          <a:bodyPr wrap="square"/>
+          <a:lstStyle/>
+          <a:p>
+            <a:pPr algn="l">
+              <a:spcAft>
+                <a:spcPts val="1200"/>
+              </a:spcAft>
+            </a:pPr>
+            <a:r>
+              <a:rPr sz="1800" b="1" i="0">
+                <a:solidFill>
+                  <a:srgbClr val="4A90D9"/>
+                </a:solidFill>
+                <a:latin typeface="Lato"/>
+              </a:rPr>
+              <a:t>1.  </a:t>
+            </a:r>
+            <a:r>
+              <a:rPr sz="1800" b="0" i="0">
+                <a:solidFill>
+                  <a:srgbClr val="E0E0E0"/>
+                </a:solidFill>
+                <a:latin typeface="Lato"/>
+              </a:rPr>
+              <a:t>Create your home base and first project folder:</a:t>
+            </a:r>
+          </a:p>
+          <a:p>
+            <a:pPr algn="l">
+              <a:spcAft>
+                <a:spcPts val="1200"/>
+              </a:spcAft>
+            </a:pPr>
+            <a:r>
+              <a:rPr sz="1800" b="1" i="0">
+                <a:solidFill>
+                  <a:srgbClr val="4A90D9"/>
+                </a:solidFill>
+                <a:latin typeface="Lato"/>
+              </a:rPr>
+              <a:t>2.  </a:t>
+            </a:r>
+            <a:r>
+              <a:rPr sz="1800" b="0" i="0">
+                <a:solidFill>
+                  <a:srgbClr val="E0E0E0"/>
+                </a:solidFill>
+                <a:latin typeface="Lato"/>
+              </a:rPr>
+              <a:t>Start Claude Code:</a:t>
+            </a:r>
+          </a:p>
+          <a:p>
+            <a:pPr algn="l">
+              <a:spcAft>
+                <a:spcPts val="1200"/>
+              </a:spcAft>
+            </a:pPr>
+            <a:r>
+              <a:rPr sz="1800" b="1" i="0">
+                <a:solidFill>
+                  <a:srgbClr val="4A90D9"/>
+                </a:solidFill>
+                <a:latin typeface="Lato"/>
+              </a:rPr>
+              <a:t>3.  </a:t>
+            </a:r>
+            <a:r>
+              <a:rPr sz="1800" b="0" i="0">
+                <a:solidFill>
+                  <a:srgbClr val="E0E0E0"/>
+                </a:solidFill>
+                <a:latin typeface="Lato"/>
+              </a:rPr>
+              <a:t>Type a prompt — your first instruction to Claude:</a:t>
+            </a:r>
+          </a:p>
+          <a:p>
+            <a:pPr algn="l">
+              <a:spcAft>
+                <a:spcPts val="1200"/>
+              </a:spcAft>
+            </a:pPr>
+            <a:r>
+              <a:rPr sz="1800" b="1" i="0">
+                <a:solidFill>
+                  <a:srgbClr val="4A90D9"/>
+                </a:solidFill>
+                <a:latin typeface="Lato"/>
+              </a:rPr>
+              <a:t>4.  </a:t>
+            </a:r>
+            <a:r>
+              <a:rPr sz="1800" b="0" i="0">
+                <a:solidFill>
+                  <a:srgbClr val="E0E0E0"/>
+                </a:solidFill>
+                <a:latin typeface="Lato"/>
+              </a:rPr>
+              <a:t>Claude will create a file. Open it in your browser — **you just built a webpage without writing a line of code.**</a:t>
+            </a:r>
+          </a:p>
+          <a:p>
+            <a:pPr algn="l">
+              <a:spcAft>
+                <a:spcPts val="1200"/>
+              </a:spcAft>
+            </a:pPr>
+            <a:r>
+              <a:rPr sz="1800" b="1" i="0">
+                <a:solidFill>
+                  <a:srgbClr val="4A90D9"/>
+                </a:solidFill>
+                <a:latin typeface="Lato"/>
+              </a:rPr>
+              <a:t>5.  </a:t>
+            </a:r>
+            <a:r>
+              <a:rPr sz="1800" b="0" i="0">
+                <a:solidFill>
+                  <a:srgbClr val="E0E0E0"/>
+                </a:solidFill>
+                <a:latin typeface="Lato"/>
+              </a:rPr>
+              <a:t>Now iterate — tell Claude:</a:t>
+            </a:r>
+          </a:p>
+          <a:p>
+            <a:pPr algn="l">
+              <a:spcAft>
+                <a:spcPts val="1200"/>
+              </a:spcAft>
+            </a:pPr>
+            <a:r>
+              <a:rPr sz="1800" b="1" i="0">
+                <a:solidFill>
+                  <a:srgbClr val="4A90D9"/>
+                </a:solidFill>
+                <a:latin typeface="Lato"/>
+              </a:rPr>
+              <a:t>6.  </a:t>
+            </a:r>
+            <a:r>
+              <a:rPr sz="1800" b="0" i="0">
+                <a:solidFill>
+                  <a:srgbClr val="E0E0E0"/>
+                </a:solidFill>
+                <a:latin typeface="Lato"/>
+              </a:rPr>
+              <a:t>Refresh your browser. See the changes. **This describe-and-build loop is how you'll work from now on.**</a:t>
+            </a:r>
           </a:p>
         </p:txBody>
       </p:sp>
@@ -4928,7 +5130,7 @@
                 </a:solidFill>
                 <a:latin typeface="Lato"/>
               </a:rPr>
-              <a:t>You Already Use Google Drive — Think of GitHub as Drive for Business Logic</a:t>
+              <a:t>Ctrl+C — Your Emergency Brake</a:t>
             </a:r>
           </a:p>
         </p:txBody>
@@ -4985,6 +5187,214 @@
 </file>
 
 <file path=ppt/slides/slide21.xml><?xml version="1.0" encoding="utf-8"?>
+<p:sld xmlns:a="http://schemas.openxmlformats.org/drawingml/2006/main" xmlns:p="http://schemas.openxmlformats.org/presentationml/2006/main" xmlns:r="http://schemas.openxmlformats.org/officeDocument/2006/relationships">
+  <p:cSld>
+    <p:bg>
+      <p:bgPr>
+        <a:solidFill>
+          <a:srgbClr val="1A1A2E"/>
+        </a:solidFill>
+        <a:effectLst/>
+      </p:bgPr>
+    </p:bg>
+    <p:spTree>
+      <p:nvGrpSpPr>
+        <p:cNvPr id="1" name=""/>
+        <p:cNvGrpSpPr/>
+        <p:nvPr/>
+      </p:nvGrpSpPr>
+      <p:grpSpPr/>
+      <p:sp>
+        <p:nvSpPr>
+          <p:cNvPr id="2" name="TextBox 1"/>
+          <p:cNvSpPr txBox="1"/>
+          <p:nvPr/>
+        </p:nvSpPr>
+        <p:spPr>
+          <a:xfrm>
+            <a:off x="914400" y="2560320"/>
+            <a:ext cx="10362895" cy="1371600"/>
+          </a:xfrm>
+          <a:prstGeom prst="rect">
+            <a:avLst/>
+          </a:prstGeom>
+          <a:noFill/>
+        </p:spPr>
+        <p:txBody>
+          <a:bodyPr wrap="square">
+            <a:spAutoFit/>
+          </a:bodyPr>
+          <a:lstStyle/>
+          <a:p>
+            <a:pPr algn="ctr"/>
+            <a:r>
+              <a:rPr sz="3200" b="1" i="0">
+                <a:solidFill>
+                  <a:srgbClr val="FFFFFF"/>
+                </a:solidFill>
+                <a:latin typeface="Lato"/>
+              </a:rPr>
+              <a:t>Why Git and GitHub?</a:t>
+            </a:r>
+          </a:p>
+        </p:txBody>
+      </p:sp>
+      <p:sp>
+        <p:nvSpPr>
+          <p:cNvPr id="3" name="Rectangle 2"/>
+          <p:cNvSpPr/>
+          <p:nvPr/>
+        </p:nvSpPr>
+        <p:spPr>
+          <a:xfrm>
+            <a:off x="4724247" y="4114800"/>
+            <a:ext cx="2743200" cy="54864"/>
+          </a:xfrm>
+          <a:prstGeom prst="rect">
+            <a:avLst/>
+          </a:prstGeom>
+          <a:solidFill>
+            <a:srgbClr val="4A90D9"/>
+          </a:solidFill>
+          <a:ln>
+            <a:noFill/>
+          </a:ln>
+        </p:spPr>
+        <p:style>
+          <a:lnRef idx="1">
+            <a:schemeClr val="accent1"/>
+          </a:lnRef>
+          <a:fillRef idx="3">
+            <a:schemeClr val="accent1"/>
+          </a:fillRef>
+          <a:effectRef idx="2">
+            <a:schemeClr val="accent1"/>
+          </a:effectRef>
+          <a:fontRef idx="minor">
+            <a:schemeClr val="lt1"/>
+          </a:fontRef>
+        </p:style>
+        <p:txBody>
+          <a:bodyPr rtlCol="0" anchor="ctr"/>
+          <a:lstStyle/>
+          <a:p>
+            <a:pPr algn="ctr"/>
+          </a:p>
+        </p:txBody>
+      </p:sp>
+    </p:spTree>
+  </p:cSld>
+  <p:clrMapOvr>
+    <a:masterClrMapping/>
+  </p:clrMapOvr>
+</p:sld>
+</file>
+
+<file path=ppt/slides/slide22.xml><?xml version="1.0" encoding="utf-8"?>
+<p:sld xmlns:a="http://schemas.openxmlformats.org/drawingml/2006/main" xmlns:p="http://schemas.openxmlformats.org/presentationml/2006/main" xmlns:r="http://schemas.openxmlformats.org/officeDocument/2006/relationships">
+  <p:cSld>
+    <p:bg>
+      <p:bgPr>
+        <a:solidFill>
+          <a:srgbClr val="1A1A2E"/>
+        </a:solidFill>
+        <a:effectLst/>
+      </p:bgPr>
+    </p:bg>
+    <p:spTree>
+      <p:nvGrpSpPr>
+        <p:cNvPr id="1" name=""/>
+        <p:cNvGrpSpPr/>
+        <p:nvPr/>
+      </p:nvGrpSpPr>
+      <p:grpSpPr/>
+      <p:sp>
+        <p:nvSpPr>
+          <p:cNvPr id="2" name="TextBox 1"/>
+          <p:cNvSpPr txBox="1"/>
+          <p:nvPr/>
+        </p:nvSpPr>
+        <p:spPr>
+          <a:xfrm>
+            <a:off x="914400" y="2560320"/>
+            <a:ext cx="10362895" cy="1371600"/>
+          </a:xfrm>
+          <a:prstGeom prst="rect">
+            <a:avLst/>
+          </a:prstGeom>
+          <a:noFill/>
+        </p:spPr>
+        <p:txBody>
+          <a:bodyPr wrap="square">
+            <a:spAutoFit/>
+          </a:bodyPr>
+          <a:lstStyle/>
+          <a:p>
+            <a:pPr algn="ctr"/>
+            <a:r>
+              <a:rPr sz="3200" b="1" i="0">
+                <a:solidFill>
+                  <a:srgbClr val="FFFFFF"/>
+                </a:solidFill>
+                <a:latin typeface="Lato"/>
+              </a:rPr>
+              <a:t>You Already Use Google Drive — Think of GitHub as Drive for Business Logic</a:t>
+            </a:r>
+          </a:p>
+        </p:txBody>
+      </p:sp>
+      <p:sp>
+        <p:nvSpPr>
+          <p:cNvPr id="3" name="Rectangle 2"/>
+          <p:cNvSpPr/>
+          <p:nvPr/>
+        </p:nvSpPr>
+        <p:spPr>
+          <a:xfrm>
+            <a:off x="4724247" y="4114800"/>
+            <a:ext cx="2743200" cy="54864"/>
+          </a:xfrm>
+          <a:prstGeom prst="rect">
+            <a:avLst/>
+          </a:prstGeom>
+          <a:solidFill>
+            <a:srgbClr val="4A90D9"/>
+          </a:solidFill>
+          <a:ln>
+            <a:noFill/>
+          </a:ln>
+        </p:spPr>
+        <p:style>
+          <a:lnRef idx="1">
+            <a:schemeClr val="accent1"/>
+          </a:lnRef>
+          <a:fillRef idx="3">
+            <a:schemeClr val="accent1"/>
+          </a:fillRef>
+          <a:effectRef idx="2">
+            <a:schemeClr val="accent1"/>
+          </a:effectRef>
+          <a:fontRef idx="minor">
+            <a:schemeClr val="lt1"/>
+          </a:fontRef>
+        </p:style>
+        <p:txBody>
+          <a:bodyPr rtlCol="0" anchor="ctr"/>
+          <a:lstStyle/>
+          <a:p>
+            <a:pPr algn="ctr"/>
+          </a:p>
+        </p:txBody>
+      </p:sp>
+    </p:spTree>
+  </p:cSld>
+  <p:clrMapOvr>
+    <a:masterClrMapping/>
+  </p:clrMapOvr>
+</p:sld>
+</file>
+
+<file path=ppt/slides/slide23.xml><?xml version="1.0" encoding="utf-8"?>
 <p:sld xmlns:a="http://schemas.openxmlformats.org/drawingml/2006/main" xmlns:p="http://schemas.openxmlformats.org/presentationml/2006/main" xmlns:r="http://schemas.openxmlformats.org/officeDocument/2006/relationships">
   <p:cSld>
     <p:bg>
@@ -5292,7 +5702,7 @@
 </p:sld>
 </file>
 
-<file path=ppt/slides/slide22.xml><?xml version="1.0" encoding="utf-8"?>
+<file path=ppt/slides/slide24.xml><?xml version="1.0" encoding="utf-8"?>
 <p:sld xmlns:a="http://schemas.openxmlformats.org/drawingml/2006/main" xmlns:p="http://schemas.openxmlformats.org/presentationml/2006/main" xmlns:r="http://schemas.openxmlformats.org/officeDocument/2006/relationships">
   <p:cSld>
     <p:bg>
@@ -5627,214 +6037,6 @@
 </p:sld>
 </file>
 
-<file path=ppt/slides/slide23.xml><?xml version="1.0" encoding="utf-8"?>
-<p:sld xmlns:a="http://schemas.openxmlformats.org/drawingml/2006/main" xmlns:p="http://schemas.openxmlformats.org/presentationml/2006/main" xmlns:r="http://schemas.openxmlformats.org/officeDocument/2006/relationships">
-  <p:cSld>
-    <p:bg>
-      <p:bgPr>
-        <a:solidFill>
-          <a:srgbClr val="1A1A2E"/>
-        </a:solidFill>
-        <a:effectLst/>
-      </p:bgPr>
-    </p:bg>
-    <p:spTree>
-      <p:nvGrpSpPr>
-        <p:cNvPr id="1" name=""/>
-        <p:cNvGrpSpPr/>
-        <p:nvPr/>
-      </p:nvGrpSpPr>
-      <p:grpSpPr/>
-      <p:sp>
-        <p:nvSpPr>
-          <p:cNvPr id="2" name="TextBox 1"/>
-          <p:cNvSpPr txBox="1"/>
-          <p:nvPr/>
-        </p:nvSpPr>
-        <p:spPr>
-          <a:xfrm>
-            <a:off x="914400" y="2560320"/>
-            <a:ext cx="10362895" cy="1371600"/>
-          </a:xfrm>
-          <a:prstGeom prst="rect">
-            <a:avLst/>
-          </a:prstGeom>
-          <a:noFill/>
-        </p:spPr>
-        <p:txBody>
-          <a:bodyPr wrap="square">
-            <a:spAutoFit/>
-          </a:bodyPr>
-          <a:lstStyle/>
-          <a:p>
-            <a:pPr algn="ctr"/>
-            <a:r>
-              <a:rPr sz="3200" b="1" i="0">
-                <a:solidFill>
-                  <a:srgbClr val="FFFFFF"/>
-                </a:solidFill>
-                <a:latin typeface="Lato"/>
-              </a:rPr>
-              <a:t>How Oren Will Work Going Forward</a:t>
-            </a:r>
-          </a:p>
-        </p:txBody>
-      </p:sp>
-      <p:sp>
-        <p:nvSpPr>
-          <p:cNvPr id="3" name="Rectangle 2"/>
-          <p:cNvSpPr/>
-          <p:nvPr/>
-        </p:nvSpPr>
-        <p:spPr>
-          <a:xfrm>
-            <a:off x="4724247" y="4114800"/>
-            <a:ext cx="2743200" cy="54864"/>
-          </a:xfrm>
-          <a:prstGeom prst="rect">
-            <a:avLst/>
-          </a:prstGeom>
-          <a:solidFill>
-            <a:srgbClr val="4A90D9"/>
-          </a:solidFill>
-          <a:ln>
-            <a:noFill/>
-          </a:ln>
-        </p:spPr>
-        <p:style>
-          <a:lnRef idx="1">
-            <a:schemeClr val="accent1"/>
-          </a:lnRef>
-          <a:fillRef idx="3">
-            <a:schemeClr val="accent1"/>
-          </a:fillRef>
-          <a:effectRef idx="2">
-            <a:schemeClr val="accent1"/>
-          </a:effectRef>
-          <a:fontRef idx="minor">
-            <a:schemeClr val="lt1"/>
-          </a:fontRef>
-        </p:style>
-        <p:txBody>
-          <a:bodyPr rtlCol="0" anchor="ctr"/>
-          <a:lstStyle/>
-          <a:p>
-            <a:pPr algn="ctr"/>
-          </a:p>
-        </p:txBody>
-      </p:sp>
-    </p:spTree>
-  </p:cSld>
-  <p:clrMapOvr>
-    <a:masterClrMapping/>
-  </p:clrMapOvr>
-</p:sld>
-</file>
-
-<file path=ppt/slides/slide24.xml><?xml version="1.0" encoding="utf-8"?>
-<p:sld xmlns:a="http://schemas.openxmlformats.org/drawingml/2006/main" xmlns:p="http://schemas.openxmlformats.org/presentationml/2006/main" xmlns:r="http://schemas.openxmlformats.org/officeDocument/2006/relationships">
-  <p:cSld>
-    <p:bg>
-      <p:bgPr>
-        <a:solidFill>
-          <a:srgbClr val="1A1A2E"/>
-        </a:solidFill>
-        <a:effectLst/>
-      </p:bgPr>
-    </p:bg>
-    <p:spTree>
-      <p:nvGrpSpPr>
-        <p:cNvPr id="1" name=""/>
-        <p:cNvGrpSpPr/>
-        <p:nvPr/>
-      </p:nvGrpSpPr>
-      <p:grpSpPr/>
-      <p:sp>
-        <p:nvSpPr>
-          <p:cNvPr id="2" name="TextBox 1"/>
-          <p:cNvSpPr txBox="1"/>
-          <p:nvPr/>
-        </p:nvSpPr>
-        <p:spPr>
-          <a:xfrm>
-            <a:off x="914400" y="2560320"/>
-            <a:ext cx="10362895" cy="1371600"/>
-          </a:xfrm>
-          <a:prstGeom prst="rect">
-            <a:avLst/>
-          </a:prstGeom>
-          <a:noFill/>
-        </p:spPr>
-        <p:txBody>
-          <a:bodyPr wrap="square">
-            <a:spAutoFit/>
-          </a:bodyPr>
-          <a:lstStyle/>
-          <a:p>
-            <a:pPr algn="ctr"/>
-            <a:r>
-              <a:rPr sz="3200" b="1" i="0">
-                <a:solidFill>
-                  <a:srgbClr val="FFFFFF"/>
-                </a:solidFill>
-                <a:latin typeface="Lato"/>
-              </a:rPr>
-              <a:t>Connecting to GitHub</a:t>
-            </a:r>
-          </a:p>
-        </p:txBody>
-      </p:sp>
-      <p:sp>
-        <p:nvSpPr>
-          <p:cNvPr id="3" name="Rectangle 2"/>
-          <p:cNvSpPr/>
-          <p:nvPr/>
-        </p:nvSpPr>
-        <p:spPr>
-          <a:xfrm>
-            <a:off x="4724247" y="4114800"/>
-            <a:ext cx="2743200" cy="54864"/>
-          </a:xfrm>
-          <a:prstGeom prst="rect">
-            <a:avLst/>
-          </a:prstGeom>
-          <a:solidFill>
-            <a:srgbClr val="4A90D9"/>
-          </a:solidFill>
-          <a:ln>
-            <a:noFill/>
-          </a:ln>
-        </p:spPr>
-        <p:style>
-          <a:lnRef idx="1">
-            <a:schemeClr val="accent1"/>
-          </a:lnRef>
-          <a:fillRef idx="3">
-            <a:schemeClr val="accent1"/>
-          </a:fillRef>
-          <a:effectRef idx="2">
-            <a:schemeClr val="accent1"/>
-          </a:effectRef>
-          <a:fontRef idx="minor">
-            <a:schemeClr val="lt1"/>
-          </a:fontRef>
-        </p:style>
-        <p:txBody>
-          <a:bodyPr rtlCol="0" anchor="ctr"/>
-          <a:lstStyle/>
-          <a:p>
-            <a:pPr algn="ctr"/>
-          </a:p>
-        </p:txBody>
-      </p:sp>
-    </p:spTree>
-  </p:cSld>
-  <p:clrMapOvr>
-    <a:masterClrMapping/>
-  </p:clrMapOvr>
-</p:sld>
-</file>
-
 <file path=ppt/slides/slide25.xml><?xml version="1.0" encoding="utf-8"?>
 <p:sld xmlns:a="http://schemas.openxmlformats.org/drawingml/2006/main" xmlns:p="http://schemas.openxmlformats.org/presentationml/2006/main" xmlns:r="http://schemas.openxmlformats.org/officeDocument/2006/relationships">
   <p:cSld>
@@ -5861,8 +6063,8 @@
         </p:nvSpPr>
         <p:spPr>
           <a:xfrm>
-            <a:off x="731520" y="365760"/>
-            <a:ext cx="10728655" cy="914400"/>
+            <a:off x="914400" y="2560320"/>
+            <a:ext cx="10362895" cy="1371600"/>
           </a:xfrm>
           <a:prstGeom prst="rect">
             <a:avLst/>
@@ -5870,18 +6072,20 @@
           <a:noFill/>
         </p:spPr>
         <p:txBody>
-          <a:bodyPr wrap="square"/>
-          <a:lstStyle/>
-          <a:p>
-            <a:pPr algn="l"/>
-            <a:r>
-              <a:rPr sz="2800" b="1" i="0">
+          <a:bodyPr wrap="square">
+            <a:spAutoFit/>
+          </a:bodyPr>
+          <a:lstStyle/>
+          <a:p>
+            <a:pPr algn="ctr"/>
+            <a:r>
+              <a:rPr sz="3200" b="1" i="0">
                 <a:solidFill>
                   <a:srgbClr val="FFFFFF"/>
                 </a:solidFill>
                 <a:latin typeface="Lato"/>
               </a:rPr>
-              <a:t>Let's Set It Up</a:t>
+              <a:t>How Oren Will Work Going Forward</a:t>
             </a:r>
           </a:p>
         </p:txBody>
@@ -5894,8 +6098,8 @@
         </p:nvSpPr>
         <p:spPr>
           <a:xfrm>
-            <a:off x="5181447" y="1325880"/>
-            <a:ext cx="1828800" cy="54864"/>
+            <a:off x="4724247" y="4114800"/>
+            <a:ext cx="2743200" cy="54864"/>
           </a:xfrm>
           <a:prstGeom prst="rect">
             <a:avLst/>
@@ -5926,137 +6130,6 @@
           <a:lstStyle/>
           <a:p>
             <a:pPr algn="ctr"/>
-          </a:p>
-        </p:txBody>
-      </p:sp>
-      <p:sp>
-        <p:nvSpPr>
-          <p:cNvPr id="4" name="TextBox 3"/>
-          <p:cNvSpPr txBox="1"/>
-          <p:nvPr/>
-        </p:nvSpPr>
-        <p:spPr>
-          <a:xfrm>
-            <a:off x="731520" y="1645920"/>
-            <a:ext cx="10728655" cy="4754880"/>
-          </a:xfrm>
-          <a:prstGeom prst="rect">
-            <a:avLst/>
-          </a:prstGeom>
-          <a:noFill/>
-        </p:spPr>
-        <p:txBody>
-          <a:bodyPr wrap="square"/>
-          <a:lstStyle/>
-          <a:p>
-            <a:pPr algn="l">
-              <a:spcAft>
-                <a:spcPts val="1000"/>
-              </a:spcAft>
-            </a:pPr>
-            <a:r>
-              <a:rPr sz="1800" b="1" i="0">
-                <a:solidFill>
-                  <a:srgbClr val="4A90D9"/>
-                </a:solidFill>
-                <a:latin typeface="Lato"/>
-              </a:rPr>
-              <a:t>•  Saved</a:t>
-            </a:r>
-            <a:r>
-              <a:rPr sz="1800" b="0" i="0">
-                <a:solidFill>
-                  <a:srgbClr val="E0E0E0"/>
-                </a:solidFill>
-                <a:latin typeface="Lato"/>
-              </a:rPr>
-              <a:t> — never lose a project again</a:t>
-            </a:r>
-          </a:p>
-          <a:p>
-            <a:pPr algn="l">
-              <a:spcAft>
-                <a:spcPts val="1000"/>
-              </a:spcAft>
-            </a:pPr>
-            <a:r>
-              <a:rPr sz="1800" b="1" i="0">
-                <a:solidFill>
-                  <a:srgbClr val="4A90D9"/>
-                </a:solidFill>
-                <a:latin typeface="Lato"/>
-              </a:rPr>
-              <a:t>•  Shareable</a:t>
-            </a:r>
-            <a:r>
-              <a:rPr sz="1800" b="0" i="0">
-                <a:solidFill>
-                  <a:srgbClr val="E0E0E0"/>
-                </a:solidFill>
-                <a:latin typeface="Lato"/>
-              </a:rPr>
-              <a:t> — your team can see what you've built</a:t>
-            </a:r>
-          </a:p>
-          <a:p>
-            <a:pPr algn="l">
-              <a:spcAft>
-                <a:spcPts val="1000"/>
-              </a:spcAft>
-            </a:pPr>
-            <a:r>
-              <a:rPr sz="1800" b="1" i="0">
-                <a:solidFill>
-                  <a:srgbClr val="4A90D9"/>
-                </a:solidFill>
-                <a:latin typeface="Lato"/>
-              </a:rPr>
-              <a:t>•  Version-tracked</a:t>
-            </a:r>
-            <a:r>
-              <a:rPr sz="1800" b="0" i="0">
-                <a:solidFill>
-                  <a:srgbClr val="E0E0E0"/>
-                </a:solidFill>
-                <a:latin typeface="Lato"/>
-              </a:rPr>
-              <a:t> — you can always go back to an earlier version</a:t>
-            </a:r>
-          </a:p>
-        </p:txBody>
-      </p:sp>
-      <p:sp>
-        <p:nvSpPr>
-          <p:cNvPr id="5" name="TextBox 4"/>
-          <p:cNvSpPr txBox="1"/>
-          <p:nvPr/>
-        </p:nvSpPr>
-        <p:spPr>
-          <a:xfrm>
-            <a:off x="1005840" y="5669280"/>
-            <a:ext cx="10180015" cy="640080"/>
-          </a:xfrm>
-          <a:prstGeom prst="rect">
-            <a:avLst/>
-          </a:prstGeom>
-          <a:noFill/>
-        </p:spPr>
-        <p:txBody>
-          <a:bodyPr wrap="square">
-            <a:spAutoFit/>
-          </a:bodyPr>
-          <a:lstStyle/>
-          <a:p>
-            <a:pPr algn="l"/>
-            <a:r>
-              <a:rPr sz="1600" b="0" i="1">
-                <a:solidFill>
-                  <a:srgbClr val="4A90D9"/>
-                </a:solidFill>
-                <a:latin typeface="Lato"/>
-              </a:rPr>
-              <a:t>“Install the GitHub command-line tool for me”</a:t>
-            </a:r>
           </a:p>
         </p:txBody>
       </p:sp>
@@ -6116,7 +6189,7 @@
                 </a:solidFill>
                 <a:latin typeface="Lato"/>
               </a:rPr>
-              <a:t>Step 1: Ask Claude to Install the GitHub Tool</a:t>
+              <a:t>Connecting to GitHub</a:t>
             </a:r>
           </a:p>
         </p:txBody>
@@ -6218,29 +6291,27 @@
                 </a:solidFill>
                 <a:latin typeface="Lato"/>
               </a:rPr>
-              <a:t>Step 2: Log In to GitHub (The One Time You Leave Claude)</a:t>
-            </a:r>
-          </a:p>
-        </p:txBody>
-      </p:sp>
-      <p:sp>
-        <p:nvSpPr>
-          <p:cNvPr id="3" name="Rounded Rectangle 2"/>
+              <a:t>Let's Set It Up</a:t>
+            </a:r>
+          </a:p>
+        </p:txBody>
+      </p:sp>
+      <p:sp>
+        <p:nvSpPr>
+          <p:cNvPr id="3" name="Rectangle 2"/>
           <p:cNvSpPr/>
           <p:nvPr/>
         </p:nvSpPr>
         <p:spPr>
           <a:xfrm>
-            <a:off x="640080" y="1463040"/>
-            <a:ext cx="10911535" cy="4937760"/>
-          </a:xfrm>
-          <a:prstGeom prst="roundRect">
-            <a:avLst>
-              <a:gd name="adj" fmla="val 2000"/>
-            </a:avLst>
+            <a:off x="5181447" y="1325880"/>
+            <a:ext cx="1828800" cy="54864"/>
+          </a:xfrm>
+          <a:prstGeom prst="rect">
+            <a:avLst/>
           </a:prstGeom>
           <a:solidFill>
-            <a:srgbClr val="16213E"/>
+            <a:srgbClr val="4A90D9"/>
           </a:solidFill>
           <a:ln>
             <a:noFill/>
@@ -6276,8 +6347,8 @@
         </p:nvSpPr>
         <p:spPr>
           <a:xfrm>
-            <a:off x="914400" y="1645920"/>
-            <a:ext cx="10545775" cy="4572000"/>
+            <a:off x="731520" y="1645920"/>
+            <a:ext cx="10728655" cy="4754880"/>
           </a:xfrm>
           <a:prstGeom prst="rect">
             <a:avLst/>
@@ -6288,19 +6359,113 @@
           <a:bodyPr wrap="square"/>
           <a:lstStyle/>
           <a:p>
-            <a:pPr>
+            <a:pPr algn="l">
               <a:spcAft>
-                <a:spcPts val="200"/>
+                <a:spcPts val="1000"/>
               </a:spcAft>
             </a:pPr>
             <a:r>
-              <a:rPr sz="1400" b="0" i="0">
+              <a:rPr sz="1800" b="1" i="0">
+                <a:solidFill>
+                  <a:srgbClr val="4A90D9"/>
+                </a:solidFill>
+                <a:latin typeface="Lato"/>
+              </a:rPr>
+              <a:t>•  Saved</a:t>
+            </a:r>
+            <a:r>
+              <a:rPr sz="1800" b="0" i="0">
                 <a:solidFill>
                   <a:srgbClr val="E0E0E0"/>
                 </a:solidFill>
-                <a:latin typeface="Consolas"/>
-              </a:rPr>
-              <a:t>   gh auth login</a:t>
+                <a:latin typeface="Lato"/>
+              </a:rPr>
+              <a:t> — never lose a project again</a:t>
+            </a:r>
+          </a:p>
+          <a:p>
+            <a:pPr algn="l">
+              <a:spcAft>
+                <a:spcPts val="1000"/>
+              </a:spcAft>
+            </a:pPr>
+            <a:r>
+              <a:rPr sz="1800" b="1" i="0">
+                <a:solidFill>
+                  <a:srgbClr val="4A90D9"/>
+                </a:solidFill>
+                <a:latin typeface="Lato"/>
+              </a:rPr>
+              <a:t>•  Shareable</a:t>
+            </a:r>
+            <a:r>
+              <a:rPr sz="1800" b="0" i="0">
+                <a:solidFill>
+                  <a:srgbClr val="E0E0E0"/>
+                </a:solidFill>
+                <a:latin typeface="Lato"/>
+              </a:rPr>
+              <a:t> — your team can see what you've built</a:t>
+            </a:r>
+          </a:p>
+          <a:p>
+            <a:pPr algn="l">
+              <a:spcAft>
+                <a:spcPts val="1000"/>
+              </a:spcAft>
+            </a:pPr>
+            <a:r>
+              <a:rPr sz="1800" b="1" i="0">
+                <a:solidFill>
+                  <a:srgbClr val="4A90D9"/>
+                </a:solidFill>
+                <a:latin typeface="Lato"/>
+              </a:rPr>
+              <a:t>•  Version-tracked</a:t>
+            </a:r>
+            <a:r>
+              <a:rPr sz="1800" b="0" i="0">
+                <a:solidFill>
+                  <a:srgbClr val="E0E0E0"/>
+                </a:solidFill>
+                <a:latin typeface="Lato"/>
+              </a:rPr>
+              <a:t> — you can always go back to an earlier version</a:t>
+            </a:r>
+          </a:p>
+        </p:txBody>
+      </p:sp>
+      <p:sp>
+        <p:nvSpPr>
+          <p:cNvPr id="5" name="TextBox 4"/>
+          <p:cNvSpPr txBox="1"/>
+          <p:nvPr/>
+        </p:nvSpPr>
+        <p:spPr>
+          <a:xfrm>
+            <a:off x="1005840" y="5669280"/>
+            <a:ext cx="10180015" cy="640080"/>
+          </a:xfrm>
+          <a:prstGeom prst="rect">
+            <a:avLst/>
+          </a:prstGeom>
+          <a:noFill/>
+        </p:spPr>
+        <p:txBody>
+          <a:bodyPr wrap="square">
+            <a:spAutoFit/>
+          </a:bodyPr>
+          <a:lstStyle/>
+          <a:p>
+            <a:pPr algn="l"/>
+            <a:r>
+              <a:rPr sz="1600" b="0" i="1">
+                <a:solidFill>
+                  <a:srgbClr val="4A90D9"/>
+                </a:solidFill>
+                <a:latin typeface="Lato"/>
+              </a:rPr>
+              <a:t>“Install the GitHub command-line tool for me”</a:t>
             </a:r>
           </a:p>
         </p:txBody>
@@ -6339,8 +6504,8 @@
         </p:nvSpPr>
         <p:spPr>
           <a:xfrm>
-            <a:off x="731520" y="365760"/>
-            <a:ext cx="10728655" cy="914400"/>
+            <a:off x="914400" y="2560320"/>
+            <a:ext cx="10362895" cy="1371600"/>
           </a:xfrm>
           <a:prstGeom prst="rect">
             <a:avLst/>
@@ -6348,18 +6513,20 @@
           <a:noFill/>
         </p:spPr>
         <p:txBody>
-          <a:bodyPr wrap="square"/>
-          <a:lstStyle/>
-          <a:p>
-            <a:pPr algn="l"/>
-            <a:r>
-              <a:rPr sz="2800" b="1" i="0">
+          <a:bodyPr wrap="square">
+            <a:spAutoFit/>
+          </a:bodyPr>
+          <a:lstStyle/>
+          <a:p>
+            <a:pPr algn="ctr"/>
+            <a:r>
+              <a:rPr sz="3200" b="1" i="0">
                 <a:solidFill>
                   <a:srgbClr val="FFFFFF"/>
                 </a:solidFill>
                 <a:latin typeface="Lato"/>
               </a:rPr>
-              <a:t>Step 2: Log In to GitHub (The One Time You Leave Claude)</a:t>
+              <a:t>Step 1: Ask Claude to Install the GitHub Tool</a:t>
             </a:r>
           </a:p>
         </p:txBody>
@@ -6372,8 +6539,8 @@
         </p:nvSpPr>
         <p:spPr>
           <a:xfrm>
-            <a:off x="5181447" y="1325880"/>
-            <a:ext cx="1828800" cy="54864"/>
+            <a:off x="4724247" y="4114800"/>
+            <a:ext cx="2743200" cy="54864"/>
           </a:xfrm>
           <a:prstGeom prst="rect">
             <a:avLst/>
@@ -6404,132 +6571,6 @@
           <a:lstStyle/>
           <a:p>
             <a:pPr algn="ctr"/>
-          </a:p>
-        </p:txBody>
-      </p:sp>
-      <p:sp>
-        <p:nvSpPr>
-          <p:cNvPr id="4" name="TextBox 3"/>
-          <p:cNvSpPr txBox="1"/>
-          <p:nvPr/>
-        </p:nvSpPr>
-        <p:spPr>
-          <a:xfrm>
-            <a:off x="731520" y="1645920"/>
-            <a:ext cx="10728655" cy="4754880"/>
-          </a:xfrm>
-          <a:prstGeom prst="rect">
-            <a:avLst/>
-          </a:prstGeom>
-          <a:noFill/>
-        </p:spPr>
-        <p:txBody>
-          <a:bodyPr wrap="square"/>
-          <a:lstStyle/>
-          <a:p>
-            <a:pPr algn="l">
-              <a:spcAft>
-                <a:spcPts val="1000"/>
-              </a:spcAft>
-            </a:pPr>
-            <a:r>
-              <a:rPr sz="1800" b="1" i="0">
-                <a:solidFill>
-                  <a:srgbClr val="4A90D9"/>
-                </a:solidFill>
-                <a:latin typeface="Lato"/>
-              </a:rPr>
-              <a:t>•  GitHub.com</a:t>
-            </a:r>
-            <a:r>
-              <a:rPr sz="1800" b="0" i="0">
-                <a:solidFill>
-                  <a:srgbClr val="E0E0E0"/>
-                </a:solidFill>
-                <a:latin typeface="Lato"/>
-              </a:rPr>
-              <a:t> (not Enterprise)  — </a:t>
-            </a:r>
-            <a:r>
-              <a:rPr sz="1800" b="1" i="0">
-                <a:solidFill>
-                  <a:srgbClr val="4A90D9"/>
-                </a:solidFill>
-                <a:latin typeface="Lato"/>
-              </a:rPr>
-              <a:t>HTTPS</a:t>
-            </a:r>
-            <a:r>
-              <a:rPr sz="1800" b="0" i="0">
-                <a:solidFill>
-                  <a:srgbClr val="E0E0E0"/>
-                </a:solidFill>
-                <a:latin typeface="Lato"/>
-              </a:rPr>
-              <a:t>  — </a:t>
-            </a:r>
-            <a:r>
-              <a:rPr sz="1800" b="1" i="0">
-                <a:solidFill>
-                  <a:srgbClr val="4A90D9"/>
-                </a:solidFill>
-                <a:latin typeface="Lato"/>
-              </a:rPr>
-              <a:t>Yes</a:t>
-            </a:r>
-            <a:r>
-              <a:rPr sz="1800" b="0" i="0">
-                <a:solidFill>
-                  <a:srgbClr val="E0E0E0"/>
-                </a:solidFill>
-                <a:latin typeface="Lato"/>
-              </a:rPr>
-              <a:t> — authenticate Git with GitHub credentials  — </a:t>
-            </a:r>
-            <a:r>
-              <a:rPr sz="1800" b="1" i="0">
-                <a:solidFill>
-                  <a:srgbClr val="4A90D9"/>
-                </a:solidFill>
-                <a:latin typeface="Lato"/>
-              </a:rPr>
-              <a:t>Login with a web browser</a:t>
-            </a:r>
-          </a:p>
-        </p:txBody>
-      </p:sp>
-      <p:sp>
-        <p:nvSpPr>
-          <p:cNvPr id="5" name="TextBox 4"/>
-          <p:cNvSpPr txBox="1"/>
-          <p:nvPr/>
-        </p:nvSpPr>
-        <p:spPr>
-          <a:xfrm>
-            <a:off x="1005840" y="5669280"/>
-            <a:ext cx="10180015" cy="640080"/>
-          </a:xfrm>
-          <a:prstGeom prst="rect">
-            <a:avLst/>
-          </a:prstGeom>
-          <a:noFill/>
-        </p:spPr>
-        <p:txBody>
-          <a:bodyPr wrap="square">
-            <a:spAutoFit/>
-          </a:bodyPr>
-          <a:lstStyle/>
-          <a:p>
-            <a:pPr algn="l"/>
-            <a:r>
-              <a:rPr sz="1600" b="0" i="1">
-                <a:solidFill>
-                  <a:srgbClr val="4A90D9"/>
-                </a:solidFill>
-                <a:latin typeface="Lato"/>
-              </a:rPr>
-              <a:t>“Check if GitHub is connected”</a:t>
-            </a:r>
           </a:p>
         </p:txBody>
       </p:sp>
@@ -6567,8 +6608,8 @@
         </p:nvSpPr>
         <p:spPr>
           <a:xfrm>
-            <a:off x="914400" y="2560320"/>
-            <a:ext cx="10362895" cy="1371600"/>
+            <a:off x="731520" y="365760"/>
+            <a:ext cx="10728655" cy="914400"/>
           </a:xfrm>
           <a:prstGeom prst="rect">
             <a:avLst/>
@@ -6576,20 +6617,18 @@
           <a:noFill/>
         </p:spPr>
         <p:txBody>
-          <a:bodyPr wrap="square">
-            <a:spAutoFit/>
-          </a:bodyPr>
-          <a:lstStyle/>
-          <a:p>
-            <a:pPr algn="ctr"/>
-            <a:r>
-              <a:rPr sz="3200" b="1" i="0">
+          <a:bodyPr wrap="square"/>
+          <a:lstStyle/>
+          <a:p>
+            <a:pPr algn="l"/>
+            <a:r>
+              <a:rPr sz="2800" b="1" i="0">
                 <a:solidFill>
                   <a:srgbClr val="FFFFFF"/>
                 </a:solidFill>
                 <a:latin typeface="Lato"/>
               </a:rPr>
-              <a:t>Step 3: Verify It Worked</a:t>
+              <a:t>What is SSH? (In Plain English)</a:t>
             </a:r>
           </a:p>
         </p:txBody>
@@ -6602,8 +6641,8 @@
         </p:nvSpPr>
         <p:spPr>
           <a:xfrm>
-            <a:off x="4724247" y="4114800"/>
-            <a:ext cx="2743200" cy="54864"/>
+            <a:off x="5181447" y="1325880"/>
+            <a:ext cx="1828800" cy="54864"/>
           </a:xfrm>
           <a:prstGeom prst="rect">
             <a:avLst/>
@@ -6634,6 +6673,143 @@
           <a:lstStyle/>
           <a:p>
             <a:pPr algn="ctr"/>
+          </a:p>
+        </p:txBody>
+      </p:sp>
+      <p:sp>
+        <p:nvSpPr>
+          <p:cNvPr id="4" name="TextBox 3"/>
+          <p:cNvSpPr txBox="1"/>
+          <p:nvPr/>
+        </p:nvSpPr>
+        <p:spPr>
+          <a:xfrm>
+            <a:off x="731520" y="1645920"/>
+            <a:ext cx="10728655" cy="4754880"/>
+          </a:xfrm>
+          <a:prstGeom prst="rect">
+            <a:avLst/>
+          </a:prstGeom>
+          <a:noFill/>
+        </p:spPr>
+        <p:txBody>
+          <a:bodyPr wrap="square"/>
+          <a:lstStyle/>
+          <a:p>
+            <a:pPr algn="l">
+              <a:spcAft>
+                <a:spcPts val="1000"/>
+              </a:spcAft>
+            </a:pPr>
+            <a:r>
+              <a:rPr sz="1800" b="0" i="0">
+                <a:solidFill>
+                  <a:srgbClr val="E0E0E0"/>
+                </a:solidFill>
+                <a:latin typeface="Lato"/>
+              </a:rPr>
+              <a:t>•  SSH is how your computer and GitHub recognize each other — no password needed every time</a:t>
+            </a:r>
+          </a:p>
+          <a:p>
+            <a:pPr algn="l">
+              <a:spcAft>
+                <a:spcPts val="1000"/>
+              </a:spcAft>
+            </a:pPr>
+            <a:r>
+              <a:rPr sz="1800" b="0" i="0">
+                <a:solidFill>
+                  <a:srgbClr val="E0E0E0"/>
+                </a:solidFill>
+                <a:latin typeface="Lato"/>
+              </a:rPr>
+              <a:t>•  You create a matched pair: a </a:t>
+            </a:r>
+            <a:r>
+              <a:rPr sz="1800" b="1" i="0">
+                <a:solidFill>
+                  <a:srgbClr val="4A90D9"/>
+                </a:solidFill>
+                <a:latin typeface="Lato"/>
+              </a:rPr>
+              <a:t>public key</a:t>
+            </a:r>
+            <a:r>
+              <a:rPr sz="1800" b="0" i="0">
+                <a:solidFill>
+                  <a:srgbClr val="E0E0E0"/>
+                </a:solidFill>
+                <a:latin typeface="Lato"/>
+              </a:rPr>
+              <a:t> (like a padlock you hand to GitHub) and a </a:t>
+            </a:r>
+            <a:r>
+              <a:rPr sz="1800" b="1" i="0">
+                <a:solidFill>
+                  <a:srgbClr val="4A90D9"/>
+                </a:solidFill>
+                <a:latin typeface="Lato"/>
+              </a:rPr>
+              <a:t>private key</a:t>
+            </a:r>
+            <a:r>
+              <a:rPr sz="1800" b="0" i="0">
+                <a:solidFill>
+                  <a:srgbClr val="E0E0E0"/>
+                </a:solidFill>
+                <a:latin typeface="Lato"/>
+              </a:rPr>
+              <a:t> (like the key only your computer has)</a:t>
+            </a:r>
+          </a:p>
+          <a:p>
+            <a:pPr algn="l">
+              <a:spcAft>
+                <a:spcPts val="1000"/>
+              </a:spcAft>
+            </a:pPr>
+            <a:r>
+              <a:rPr sz="1800" b="0" i="0">
+                <a:solidFill>
+                  <a:srgbClr val="E0E0E0"/>
+                </a:solidFill>
+                <a:latin typeface="Lato"/>
+              </a:rPr>
+              <a:t>•  When your computer talks to GitHub, they check the lock and key — if they match, you're in</a:t>
+            </a:r>
+          </a:p>
+          <a:p>
+            <a:pPr algn="l">
+              <a:spcAft>
+                <a:spcPts val="1000"/>
+              </a:spcAft>
+            </a:pPr>
+            <a:r>
+              <a:rPr sz="1800" b="0" i="0">
+                <a:solidFill>
+                  <a:srgbClr val="E0E0E0"/>
+                </a:solidFill>
+                <a:latin typeface="Lato"/>
+              </a:rPr>
+              <a:t>•  You set this up once. After that, everything works automatically in the background.</a:t>
+            </a:r>
+          </a:p>
+          <a:p>
+            <a:pPr algn="l">
+              <a:spcAft>
+                <a:spcPts val="1000"/>
+              </a:spcAft>
+            </a:pPr>
+            <a:r>
+              <a:rPr sz="1800" b="0" i="0">
+                <a:solidFill>
+                  <a:srgbClr val="E0E0E0"/>
+                </a:solidFill>
+                <a:latin typeface="Lato"/>
+              </a:rPr>
+              <a:t>•  The good news: `gh auth login` handles the hard part — it generates the keys and uploads them for you</a:t>
+            </a:r>
           </a:p>
         </p:txBody>
       </p:sp>
@@ -6894,8 +7070,8 @@
         </p:nvSpPr>
         <p:spPr>
           <a:xfrm>
-            <a:off x="914400" y="2560320"/>
-            <a:ext cx="10362895" cy="1371600"/>
+            <a:off x="731520" y="365760"/>
+            <a:ext cx="10728655" cy="914400"/>
           </a:xfrm>
           <a:prstGeom prst="rect">
             <a:avLst/>
@@ -6903,20 +7079,18 @@
           <a:noFill/>
         </p:spPr>
         <p:txBody>
-          <a:bodyPr wrap="square">
-            <a:spAutoFit/>
-          </a:bodyPr>
-          <a:lstStyle/>
-          <a:p>
-            <a:pPr algn="ctr"/>
-            <a:r>
-              <a:rPr sz="3200" b="1" i="0">
+          <a:bodyPr wrap="square"/>
+          <a:lstStyle/>
+          <a:p>
+            <a:pPr algn="l"/>
+            <a:r>
+              <a:rPr sz="2800" b="1" i="0">
                 <a:solidFill>
                   <a:srgbClr val="FFFFFF"/>
                 </a:solidFill>
                 <a:latin typeface="Lato"/>
               </a:rPr>
-              <a:t>Clone the Learning Pods Repo</a:t>
+              <a:t>Step 2: Log In to GitHub via SSH (In Warp)</a:t>
             </a:r>
           </a:p>
         </p:txBody>
@@ -6929,8 +7103,8 @@
         </p:nvSpPr>
         <p:spPr>
           <a:xfrm>
-            <a:off x="4724247" y="4114800"/>
-            <a:ext cx="2743200" cy="54864"/>
+            <a:off x="5181447" y="1325880"/>
+            <a:ext cx="1828800" cy="54864"/>
           </a:xfrm>
           <a:prstGeom prst="rect">
             <a:avLst/>
@@ -6972,6 +7146,115 @@
         </p:nvSpPr>
         <p:spPr>
           <a:xfrm>
+            <a:off x="731520" y="1645920"/>
+            <a:ext cx="10728655" cy="4754880"/>
+          </a:xfrm>
+          <a:prstGeom prst="rect">
+            <a:avLst/>
+          </a:prstGeom>
+          <a:noFill/>
+        </p:spPr>
+        <p:txBody>
+          <a:bodyPr wrap="square"/>
+          <a:lstStyle/>
+          <a:p>
+            <a:pPr algn="l">
+              <a:spcAft>
+                <a:spcPts val="1000"/>
+              </a:spcAft>
+            </a:pPr>
+            <a:r>
+              <a:rPr sz="1800" b="1" i="0">
+                <a:solidFill>
+                  <a:srgbClr val="4A90D9"/>
+                </a:solidFill>
+                <a:latin typeface="Lato"/>
+              </a:rPr>
+              <a:t>•  GitHub.com</a:t>
+            </a:r>
+            <a:r>
+              <a:rPr sz="1800" b="0" i="0">
+                <a:solidFill>
+                  <a:srgbClr val="E0E0E0"/>
+                </a:solidFill>
+                <a:latin typeface="Lato"/>
+              </a:rPr>
+              <a:t> (not Enterprise)  — </a:t>
+            </a:r>
+            <a:r>
+              <a:rPr sz="1800" b="1" i="0">
+                <a:solidFill>
+                  <a:srgbClr val="4A90D9"/>
+                </a:solidFill>
+                <a:latin typeface="Lato"/>
+              </a:rPr>
+              <a:t>SSH</a:t>
+            </a:r>
+            <a:r>
+              <a:rPr sz="1800" b="0" i="0">
+                <a:solidFill>
+                  <a:srgbClr val="E0E0E0"/>
+                </a:solidFill>
+                <a:latin typeface="Lato"/>
+              </a:rPr>
+              <a:t> (not HTTPS)  — </a:t>
+            </a:r>
+            <a:r>
+              <a:rPr sz="1800" b="1" i="0">
+                <a:solidFill>
+                  <a:srgbClr val="4A90D9"/>
+                </a:solidFill>
+                <a:latin typeface="Lato"/>
+              </a:rPr>
+              <a:t>Yes</a:t>
+            </a:r>
+            <a:r>
+              <a:rPr sz="1800" b="0" i="0">
+                <a:solidFill>
+                  <a:srgbClr val="E0E0E0"/>
+                </a:solidFill>
+                <a:latin typeface="Lato"/>
+              </a:rPr>
+              <a:t> — generate a new SSH key  — Enter a name for your key, e.g. `my-laptop`, then press Enter  — </a:t>
+            </a:r>
+            <a:r>
+              <a:rPr sz="1800" b="1" i="0">
+                <a:solidFill>
+                  <a:srgbClr val="4A90D9"/>
+                </a:solidFill>
+                <a:latin typeface="Lato"/>
+              </a:rPr>
+              <a:t>Passphrase</a:t>
+            </a:r>
+            <a:r>
+              <a:rPr sz="1800" b="0" i="0">
+                <a:solidFill>
+                  <a:srgbClr val="E0E0E0"/>
+                </a:solidFill>
+                <a:latin typeface="Lato"/>
+              </a:rPr>
+              <a:t> — press Enter to leave it blank  — </a:t>
+            </a:r>
+            <a:r>
+              <a:rPr sz="1800" b="1" i="0">
+                <a:solidFill>
+                  <a:srgbClr val="4A90D9"/>
+                </a:solidFill>
+                <a:latin typeface="Lato"/>
+              </a:rPr>
+              <a:t>Login with a web browser</a:t>
+            </a:r>
+          </a:p>
+        </p:txBody>
+      </p:sp>
+      <p:sp>
+        <p:nvSpPr>
+          <p:cNvPr id="5" name="TextBox 4"/>
+          <p:cNvSpPr txBox="1"/>
+          <p:nvPr/>
+        </p:nvSpPr>
+        <p:spPr>
+          <a:xfrm>
             <a:off x="1005840" y="5669280"/>
             <a:ext cx="10180015" cy="640080"/>
           </a:xfrm>
@@ -6994,42 +7277,7 @@
                 </a:solidFill>
                 <a:latin typeface="Lato"/>
               </a:rPr>
-              <a:t>“Clone the learning pods repository from GitHub to my claude_projects folder. The repo URL is https://github.com/avasthianshul/learning-pods.git”</a:t>
-            </a:r>
-          </a:p>
-        </p:txBody>
-      </p:sp>
-      <p:sp>
-        <p:nvSpPr>
-          <p:cNvPr id="5" name="TextBox 4"/>
-          <p:cNvSpPr txBox="1"/>
-          <p:nvPr/>
-        </p:nvSpPr>
-        <p:spPr>
-          <a:xfrm>
-            <a:off x="1005840" y="5669280"/>
-            <a:ext cx="10180015" cy="640080"/>
-          </a:xfrm>
-          <a:prstGeom prst="rect">
-            <a:avLst/>
-          </a:prstGeom>
-          <a:noFill/>
-        </p:spPr>
-        <p:txBody>
-          <a:bodyPr wrap="square">
-            <a:spAutoFit/>
-          </a:bodyPr>
-          <a:lstStyle/>
-          <a:p>
-            <a:pPr algn="l"/>
-            <a:r>
-              <a:rPr sz="1600" b="0" i="1">
-                <a:solidFill>
-                  <a:srgbClr val="4A90D9"/>
-                </a:solidFill>
-                <a:latin typeface="Lato"/>
-              </a:rPr>
-              <a:t>“Open the learning_pods folder”</a:t>
+              <a:t>“Check if GitHub is connected”</a:t>
             </a:r>
           </a:p>
         </p:txBody>
@@ -7090,7 +7338,7 @@
                 </a:solidFill>
                 <a:latin typeface="Lato"/>
               </a:rPr>
-              <a:t>Get the Course Materials on Your Machine</a:t>
+              <a:t>Step 3: Verify It Worked</a:t>
             </a:r>
           </a:p>
         </p:txBody>
@@ -7194,7 +7442,7 @@
                 </a:solidFill>
                 <a:latin typeface="Lato"/>
               </a:rPr>
-              <a:t>Your Revision Dashboard</a:t>
+              <a:t>Clone the Learning Pods Repo</a:t>
             </a:r>
           </a:p>
         </p:txBody>
@@ -7296,29 +7544,27 @@
                 </a:solidFill>
                 <a:latin typeface="Lato"/>
               </a:rPr>
-              <a:t>Interactive Lecture Notes in Your Browser</a:t>
-            </a:r>
-          </a:p>
-        </p:txBody>
-      </p:sp>
-      <p:sp>
-        <p:nvSpPr>
-          <p:cNvPr id="3" name="Rounded Rectangle 2"/>
+              <a:t>Get the Course Materials on Your Machine</a:t>
+            </a:r>
+          </a:p>
+        </p:txBody>
+      </p:sp>
+      <p:sp>
+        <p:nvSpPr>
+          <p:cNvPr id="3" name="Rectangle 2"/>
           <p:cNvSpPr/>
           <p:nvPr/>
         </p:nvSpPr>
         <p:spPr>
           <a:xfrm>
-            <a:off x="640080" y="1463040"/>
-            <a:ext cx="10911535" cy="4937760"/>
-          </a:xfrm>
-          <a:prstGeom prst="roundRect">
-            <a:avLst>
-              <a:gd name="adj" fmla="val 2000"/>
-            </a:avLst>
+            <a:off x="5181447" y="1325880"/>
+            <a:ext cx="1828800" cy="54864"/>
+          </a:xfrm>
+          <a:prstGeom prst="rect">
+            <a:avLst/>
           </a:prstGeom>
           <a:solidFill>
-            <a:srgbClr val="16213E"/>
+            <a:srgbClr val="4A90D9"/>
           </a:solidFill>
           <a:ln>
             <a:noFill/>
@@ -7354,8 +7600,8 @@
         </p:nvSpPr>
         <p:spPr>
           <a:xfrm>
-            <a:off x="914400" y="1645920"/>
-            <a:ext cx="10545775" cy="4572000"/>
+            <a:off x="731520" y="1645920"/>
+            <a:ext cx="10728655" cy="4754880"/>
           </a:xfrm>
           <a:prstGeom prst="rect">
             <a:avLst/>
@@ -7366,19 +7612,128 @@
           <a:bodyPr wrap="square"/>
           <a:lstStyle/>
           <a:p>
-            <a:pPr>
+            <a:pPr algn="l">
               <a:spcAft>
-                <a:spcPts val="200"/>
+                <a:spcPts val="1200"/>
               </a:spcAft>
             </a:pPr>
             <a:r>
-              <a:rPr sz="1400" b="0" i="0">
+              <a:rPr sz="1800" b="1" i="0">
+                <a:solidFill>
+                  <a:srgbClr val="4A90D9"/>
+                </a:solidFill>
+                <a:latin typeface="Lato"/>
+              </a:rPr>
+              <a:t>1.  </a:t>
+            </a:r>
+            <a:r>
+              <a:rPr sz="1800" b="0" i="0">
                 <a:solidFill>
                   <a:srgbClr val="E0E0E0"/>
                 </a:solidFill>
-                <a:latin typeface="Consolas"/>
-              </a:rPr>
-              <a:t>~/claude_projects/learning_pods/pods/01-hello-terminal/app/index.html</a:t>
+                <a:latin typeface="Lato"/>
+              </a:rPr>
+              <a:t>Go to your Claude Code session (or open Claude Desktop)</a:t>
+            </a:r>
+          </a:p>
+          <a:p>
+            <a:pPr algn="l">
+              <a:spcAft>
+                <a:spcPts val="1200"/>
+              </a:spcAft>
+            </a:pPr>
+            <a:r>
+              <a:rPr sz="1800" b="1" i="0">
+                <a:solidFill>
+                  <a:srgbClr val="4A90D9"/>
+                </a:solidFill>
+                <a:latin typeface="Lato"/>
+              </a:rPr>
+              <a:t>2.  </a:t>
+            </a:r>
+            <a:r>
+              <a:rPr sz="1800" b="0" i="0">
+                <a:solidFill>
+                  <a:srgbClr val="E0E0E0"/>
+                </a:solidFill>
+                <a:latin typeface="Lato"/>
+              </a:rPr>
+              <a:t>Type exactly: **"Clone the learning pods repository from GitHub to my claude_projects folder. The repo URL is https://github.com/avasthianshul/learning-pods.git"**</a:t>
+            </a:r>
+          </a:p>
+          <a:p>
+            <a:pPr algn="l">
+              <a:spcAft>
+                <a:spcPts val="1200"/>
+              </a:spcAft>
+            </a:pPr>
+            <a:r>
+              <a:rPr sz="1800" b="1" i="0">
+                <a:solidFill>
+                  <a:srgbClr val="4A90D9"/>
+                </a:solidFill>
+                <a:latin typeface="Lato"/>
+              </a:rPr>
+              <a:t>3.  </a:t>
+            </a:r>
+            <a:r>
+              <a:rPr sz="1800" b="0" i="0">
+                <a:solidFill>
+                  <a:srgbClr val="E0E0E0"/>
+                </a:solidFill>
+                <a:latin typeface="Lato"/>
+              </a:rPr>
+              <a:t>Claude will run the clone command — say yes to any permission prompts</a:t>
+            </a:r>
+          </a:p>
+          <a:p>
+            <a:pPr algn="l">
+              <a:spcAft>
+                <a:spcPts val="1200"/>
+              </a:spcAft>
+            </a:pPr>
+            <a:r>
+              <a:rPr sz="1800" b="1" i="0">
+                <a:solidFill>
+                  <a:srgbClr val="4A90D9"/>
+                </a:solidFill>
+                <a:latin typeface="Lato"/>
+              </a:rPr>
+              <a:t>4.  </a:t>
+            </a:r>
+            <a:r>
+              <a:rPr sz="1800" b="0" i="0">
+                <a:solidFill>
+                  <a:srgbClr val="E0E0E0"/>
+                </a:solidFill>
+                <a:latin typeface="Lato"/>
+              </a:rPr>
+              <a:t>Once complete, type: **"Open the learning_pods folder"**</a:t>
+            </a:r>
+          </a:p>
+          <a:p>
+            <a:pPr algn="l">
+              <a:spcAft>
+                <a:spcPts val="1200"/>
+              </a:spcAft>
+            </a:pPr>
+            <a:r>
+              <a:rPr sz="1800" b="1" i="0">
+                <a:solidFill>
+                  <a:srgbClr val="4A90D9"/>
+                </a:solidFill>
+                <a:latin typeface="Lato"/>
+              </a:rPr>
+              <a:t>5.  </a:t>
+            </a:r>
+            <a:r>
+              <a:rPr sz="1800" b="0" i="0">
+                <a:solidFill>
+                  <a:srgbClr val="E0E0E0"/>
+                </a:solidFill>
+                <a:latin typeface="Lato"/>
+              </a:rPr>
+              <a:t>You now have every pod's lecture notes, exercises, and browser apps on your computer</a:t>
             </a:r>
           </a:p>
         </p:txBody>
@@ -7417,8 +7772,8 @@
         </p:nvSpPr>
         <p:spPr>
           <a:xfrm>
-            <a:off x="914400" y="2560320"/>
-            <a:ext cx="10362895" cy="1371600"/>
+            <a:off x="731520" y="365760"/>
+            <a:ext cx="10728655" cy="914400"/>
           </a:xfrm>
           <a:prstGeom prst="rect">
             <a:avLst/>
@@ -7426,20 +7781,18 @@
           <a:noFill/>
         </p:spPr>
         <p:txBody>
-          <a:bodyPr wrap="square">
-            <a:spAutoFit/>
-          </a:bodyPr>
-          <a:lstStyle/>
-          <a:p>
-            <a:pPr algn="ctr"/>
-            <a:r>
-              <a:rPr sz="3200" b="1" i="0">
+          <a:bodyPr wrap="square"/>
+          <a:lstStyle/>
+          <a:p>
+            <a:pPr algn="l"/>
+            <a:r>
+              <a:rPr sz="2800" b="1" i="0">
                 <a:solidFill>
                   <a:srgbClr val="FFFFFF"/>
                 </a:solidFill>
                 <a:latin typeface="Lato"/>
               </a:rPr>
-              <a:t>Interactive Lecture Notes in Your Browser</a:t>
+              <a:t>What Was Just Downloaded?</a:t>
             </a:r>
           </a:p>
         </p:txBody>
@@ -7452,8 +7805,8 @@
         </p:nvSpPr>
         <p:spPr>
           <a:xfrm>
-            <a:off x="4724247" y="4114800"/>
-            <a:ext cx="2743200" cy="54864"/>
+            <a:off x="5181447" y="1325880"/>
+            <a:ext cx="1828800" cy="54864"/>
           </a:xfrm>
           <a:prstGeom prst="rect">
             <a:avLst/>
@@ -7484,6 +7837,118 @@
           <a:lstStyle/>
           <a:p>
             <a:pPr algn="ctr"/>
+          </a:p>
+        </p:txBody>
+      </p:sp>
+      <p:sp>
+        <p:nvSpPr>
+          <p:cNvPr id="4" name="TextBox 3"/>
+          <p:cNvSpPr txBox="1"/>
+          <p:nvPr/>
+        </p:nvSpPr>
+        <p:spPr>
+          <a:xfrm>
+            <a:off x="731520" y="1645920"/>
+            <a:ext cx="10728655" cy="4754880"/>
+          </a:xfrm>
+          <a:prstGeom prst="rect">
+            <a:avLst/>
+          </a:prstGeom>
+          <a:noFill/>
+        </p:spPr>
+        <p:txBody>
+          <a:bodyPr wrap="square"/>
+          <a:lstStyle/>
+          <a:p>
+            <a:pPr algn="l">
+              <a:spcAft>
+                <a:spcPts val="1000"/>
+              </a:spcAft>
+            </a:pPr>
+            <a:r>
+              <a:rPr sz="1800" b="1" i="0">
+                <a:solidFill>
+                  <a:srgbClr val="4A90D9"/>
+                </a:solidFill>
+                <a:latin typeface="Lato"/>
+              </a:rPr>
+              <a:t>•  pods/</a:t>
+            </a:r>
+            <a:r>
+              <a:rPr sz="1800" b="0" i="0">
+                <a:solidFill>
+                  <a:srgbClr val="E0E0E0"/>
+                </a:solidFill>
+                <a:latin typeface="Lato"/>
+              </a:rPr>
+              <a:t> — one folder per week, containing lecture notes, exercises, and a browser app</a:t>
+            </a:r>
+          </a:p>
+          <a:p>
+            <a:pPr algn="l">
+              <a:spcAft>
+                <a:spcPts val="1000"/>
+              </a:spcAft>
+            </a:pPr>
+            <a:r>
+              <a:rPr sz="1800" b="1" i="0">
+                <a:solidFill>
+                  <a:srgbClr val="4A90D9"/>
+                </a:solidFill>
+                <a:latin typeface="Lato"/>
+              </a:rPr>
+              <a:t>•  shared/</a:t>
+            </a:r>
+            <a:r>
+              <a:rPr sz="1800" b="0" i="0">
+                <a:solidFill>
+                  <a:srgbClr val="E0E0E0"/>
+                </a:solidFill>
+                <a:latin typeface="Lato"/>
+              </a:rPr>
+              <a:t> — templates, the theme, and the PPTX generator used to make these slides</a:t>
+            </a:r>
+          </a:p>
+          <a:p>
+            <a:pPr algn="l">
+              <a:spcAft>
+                <a:spcPts val="1000"/>
+              </a:spcAft>
+            </a:pPr>
+            <a:r>
+              <a:rPr sz="1800" b="1" i="0">
+                <a:solidFill>
+                  <a:srgbClr val="4A90D9"/>
+                </a:solidFill>
+                <a:latin typeface="Lato"/>
+              </a:rPr>
+              <a:t>•  skills/</a:t>
+            </a:r>
+            <a:r>
+              <a:rPr sz="1800" b="0" i="0">
+                <a:solidFill>
+                  <a:srgbClr val="E0E0E0"/>
+                </a:solidFill>
+                <a:latin typeface="Lato"/>
+              </a:rPr>
+              <a:t> — automation tools you'll unlock in later pods</a:t>
+            </a:r>
+          </a:p>
+          <a:p>
+            <a:pPr algn="l">
+              <a:spcAft>
+                <a:spcPts val="1000"/>
+              </a:spcAft>
+            </a:pPr>
+            <a:r>
+              <a:rPr sz="1800" b="0" i="0">
+                <a:solidFill>
+                  <a:srgbClr val="E0E0E0"/>
+                </a:solidFill>
+                <a:latin typeface="Lato"/>
+              </a:rPr>
+              <a:t>•  Every pod's browser app is ready to open — no installation needed</a:t>
+            </a:r>
           </a:p>
         </p:txBody>
       </p:sp>
@@ -7543,7 +8008,7 @@
                 </a:solidFill>
                 <a:latin typeface="Lato"/>
               </a:rPr>
-              <a:t>Hands-On Exercises (30 min)</a:t>
+              <a:t>Your Revision Dashboard</a:t>
             </a:r>
           </a:p>
         </p:txBody>
@@ -7645,27 +8110,29 @@
                 </a:solidFill>
                 <a:latin typeface="Lato"/>
               </a:rPr>
-              <a:t>Exercise 1: Set Up Your Workspace (5 min)</a:t>
-            </a:r>
-          </a:p>
-        </p:txBody>
-      </p:sp>
-      <p:sp>
-        <p:nvSpPr>
-          <p:cNvPr id="3" name="Rectangle 2"/>
+              <a:t>Interactive Lecture Notes in Your Browser</a:t>
+            </a:r>
+          </a:p>
+        </p:txBody>
+      </p:sp>
+      <p:sp>
+        <p:nvSpPr>
+          <p:cNvPr id="3" name="Rounded Rectangle 2"/>
           <p:cNvSpPr/>
           <p:nvPr/>
         </p:nvSpPr>
         <p:spPr>
           <a:xfrm>
-            <a:off x="5181447" y="1325880"/>
-            <a:ext cx="1828800" cy="54864"/>
-          </a:xfrm>
-          <a:prstGeom prst="rect">
-            <a:avLst/>
+            <a:off x="640080" y="1463040"/>
+            <a:ext cx="10911535" cy="4937760"/>
+          </a:xfrm>
+          <a:prstGeom prst="roundRect">
+            <a:avLst>
+              <a:gd name="adj" fmla="val 2000"/>
+            </a:avLst>
           </a:prstGeom>
           <a:solidFill>
-            <a:srgbClr val="4A90D9"/>
+            <a:srgbClr val="16213E"/>
           </a:solidFill>
           <a:ln>
             <a:noFill/>
@@ -7701,8 +8168,8 @@
         </p:nvSpPr>
         <p:spPr>
           <a:xfrm>
-            <a:off x="731520" y="1645920"/>
-            <a:ext cx="10728655" cy="4754880"/>
+            <a:off x="914400" y="1645920"/>
+            <a:ext cx="10545775" cy="4572000"/>
           </a:xfrm>
           <a:prstGeom prst="rect">
             <a:avLst/>
@@ -7713,78 +8180,19 @@
           <a:bodyPr wrap="square"/>
           <a:lstStyle/>
           <a:p>
-            <a:pPr algn="l">
+            <a:pPr>
               <a:spcAft>
-                <a:spcPts val="1200"/>
+                <a:spcPts val="200"/>
               </a:spcAft>
             </a:pPr>
             <a:r>
-              <a:rPr sz="1800" b="1" i="0">
-                <a:solidFill>
-                  <a:srgbClr val="4A90D9"/>
-                </a:solidFill>
-                <a:latin typeface="Lato"/>
-              </a:rPr>
-              <a:t>1.  </a:t>
-            </a:r>
-            <a:r>
-              <a:rPr sz="1800" b="0" i="0">
+              <a:rPr sz="1400" b="0" i="0">
                 <a:solidFill>
                   <a:srgbClr val="E0E0E0"/>
                 </a:solidFill>
-                <a:latin typeface="Lato"/>
-              </a:rPr>
-              <a:t>Create `~/claude_projects/` if you haven't already</a:t>
-            </a:r>
-          </a:p>
-          <a:p>
-            <a:pPr algn="l">
-              <a:spcAft>
-                <a:spcPts val="1200"/>
-              </a:spcAft>
-            </a:pPr>
-            <a:r>
-              <a:rPr sz="1800" b="1" i="0">
-                <a:solidFill>
-                  <a:srgbClr val="4A90D9"/>
-                </a:solidFill>
-                <a:latin typeface="Lato"/>
-              </a:rPr>
-              <a:t>2.  </a:t>
-            </a:r>
-            <a:r>
-              <a:rPr sz="1800" b="0" i="0">
-                <a:solidFill>
-                  <a:srgbClr val="E0E0E0"/>
-                </a:solidFill>
-                <a:latin typeface="Lato"/>
-              </a:rPr>
-              <a:t>Verify with `pwd` and `ls`</a:t>
-            </a:r>
-          </a:p>
-          <a:p>
-            <a:pPr algn="l">
-              <a:spcAft>
-                <a:spcPts val="1200"/>
-              </a:spcAft>
-            </a:pPr>
-            <a:r>
-              <a:rPr sz="1800" b="1" i="0">
-                <a:solidFill>
-                  <a:srgbClr val="4A90D9"/>
-                </a:solidFill>
-                <a:latin typeface="Lato"/>
-              </a:rPr>
-              <a:t>3.  </a:t>
-            </a:r>
-            <a:r>
-              <a:rPr sz="1800" b="0" i="0">
-                <a:solidFill>
-                  <a:srgbClr val="E0E0E0"/>
-                </a:solidFill>
-                <a:latin typeface="Lato"/>
-              </a:rPr>
-              <a:t>Check it in File Explorer / Finder too — same folder, two views</a:t>
+                <a:latin typeface="Consolas"/>
+              </a:rPr>
+              <a:t>~/claude_projects/learning_pods/pods/01-hello-terminal/app/index.html</a:t>
             </a:r>
           </a:p>
         </p:txBody>
@@ -7823,8 +8231,8 @@
         </p:nvSpPr>
         <p:spPr>
           <a:xfrm>
-            <a:off x="731520" y="365760"/>
-            <a:ext cx="10728655" cy="914400"/>
+            <a:off x="914400" y="2560320"/>
+            <a:ext cx="10362895" cy="1371600"/>
           </a:xfrm>
           <a:prstGeom prst="rect">
             <a:avLst/>
@@ -7832,18 +8240,20 @@
           <a:noFill/>
         </p:spPr>
         <p:txBody>
-          <a:bodyPr wrap="square"/>
-          <a:lstStyle/>
-          <a:p>
-            <a:pPr algn="l"/>
-            <a:r>
-              <a:rPr sz="2800" b="1" i="0">
+          <a:bodyPr wrap="square">
+            <a:spAutoFit/>
+          </a:bodyPr>
+          <a:lstStyle/>
+          <a:p>
+            <a:pPr algn="ctr"/>
+            <a:r>
+              <a:rPr sz="3200" b="1" i="0">
                 <a:solidFill>
                   <a:srgbClr val="FFFFFF"/>
                 </a:solidFill>
                 <a:latin typeface="Lato"/>
               </a:rPr>
-              <a:t>Exercise 2: Your First Project (10 min)</a:t>
+              <a:t>Interactive Lecture Notes in Your Browser</a:t>
             </a:r>
           </a:p>
         </p:txBody>
@@ -7856,8 +8266,8 @@
         </p:nvSpPr>
         <p:spPr>
           <a:xfrm>
-            <a:off x="5181447" y="1325880"/>
-            <a:ext cx="1828800" cy="54864"/>
+            <a:off x="4724247" y="4114800"/>
+            <a:ext cx="2743200" cy="54864"/>
           </a:xfrm>
           <a:prstGeom prst="rect">
             <a:avLst/>
@@ -7888,127 +8298,6 @@
           <a:lstStyle/>
           <a:p>
             <a:pPr algn="ctr"/>
-          </a:p>
-        </p:txBody>
-      </p:sp>
-      <p:sp>
-        <p:nvSpPr>
-          <p:cNvPr id="4" name="TextBox 3"/>
-          <p:cNvSpPr txBox="1"/>
-          <p:nvPr/>
-        </p:nvSpPr>
-        <p:spPr>
-          <a:xfrm>
-            <a:off x="731520" y="1645920"/>
-            <a:ext cx="10728655" cy="4754880"/>
-          </a:xfrm>
-          <a:prstGeom prst="rect">
-            <a:avLst/>
-          </a:prstGeom>
-          <a:noFill/>
-        </p:spPr>
-        <p:txBody>
-          <a:bodyPr wrap="square"/>
-          <a:lstStyle/>
-          <a:p>
-            <a:pPr algn="l">
-              <a:spcAft>
-                <a:spcPts val="1200"/>
-              </a:spcAft>
-            </a:pPr>
-            <a:r>
-              <a:rPr sz="1800" b="1" i="0">
-                <a:solidFill>
-                  <a:srgbClr val="4A90D9"/>
-                </a:solidFill>
-                <a:latin typeface="Lato"/>
-              </a:rPr>
-              <a:t>1.  </a:t>
-            </a:r>
-            <a:r>
-              <a:rPr sz="1800" b="0" i="0">
-                <a:solidFill>
-                  <a:srgbClr val="E0E0E0"/>
-                </a:solidFill>
-                <a:latin typeface="Lato"/>
-              </a:rPr>
-              <a:t>Create a project folder, start Claude Code</a:t>
-            </a:r>
-          </a:p>
-          <a:p>
-            <a:pPr algn="l">
-              <a:spcAft>
-                <a:spcPts val="1200"/>
-              </a:spcAft>
-            </a:pPr>
-            <a:r>
-              <a:rPr sz="1800" b="1" i="0">
-                <a:solidFill>
-                  <a:srgbClr val="4A90D9"/>
-                </a:solidFill>
-                <a:latin typeface="Lato"/>
-              </a:rPr>
-              <a:t>2.  </a:t>
-            </a:r>
-            <a:r>
-              <a:rPr sz="1800" b="0" i="0">
-                <a:solidFill>
-                  <a:srgbClr val="E0E0E0"/>
-                </a:solidFill>
-                <a:latin typeface="Lato"/>
-              </a:rPr>
-              <a:t>Build an HTML page with your name and Oren branding</a:t>
-            </a:r>
-          </a:p>
-          <a:p>
-            <a:pPr algn="l">
-              <a:spcAft>
-                <a:spcPts val="1200"/>
-              </a:spcAft>
-            </a:pPr>
-            <a:r>
-              <a:rPr sz="1800" b="1" i="0">
-                <a:solidFill>
-                  <a:srgbClr val="4A90D9"/>
-                </a:solidFill>
-                <a:latin typeface="Lato"/>
-              </a:rPr>
-              <a:t>3.  </a:t>
-            </a:r>
-            <a:r>
-              <a:rPr sz="1800" b="0" i="0">
-                <a:solidFill>
-                  <a:srgbClr val="E0E0E0"/>
-                </a:solidFill>
-                <a:latin typeface="Lato"/>
-              </a:rPr>
-              <a:t>Iterate on it — change colors, add content, make it yours</a:t>
-            </a:r>
-          </a:p>
-          <a:p>
-            <a:pPr algn="l">
-              <a:spcAft>
-                <a:spcPts val="1200"/>
-              </a:spcAft>
-            </a:pPr>
-            <a:r>
-              <a:rPr sz="1800" b="1" i="0">
-                <a:solidFill>
-                  <a:srgbClr val="4A90D9"/>
-                </a:solidFill>
-                <a:latin typeface="Lato"/>
-              </a:rPr>
-              <a:t>4.  </a:t>
-            </a:r>
-            <a:r>
-              <a:rPr sz="1800" b="0" i="0">
-                <a:solidFill>
-                  <a:srgbClr val="E0E0E0"/>
-                </a:solidFill>
-                <a:latin typeface="Lato"/>
-              </a:rPr>
-              <a:t>Open it in your browser</a:t>
-            </a:r>
           </a:p>
         </p:txBody>
       </p:sp>
@@ -8066,7 +8355,7 @@
                 </a:solidFill>
                 <a:latin typeface="Lato"/>
               </a:rPr>
-              <a:t>Exercise 3: Connect to GitHub (10 min)</a:t>
+              <a:t>Proof of Completion</a:t>
             </a:r>
           </a:p>
         </p:txBody>
@@ -8136,76 +8425,65 @@
           <a:p>
             <a:pPr algn="l">
               <a:spcAft>
-                <a:spcPts val="1200"/>
+                <a:spcPts val="1000"/>
               </a:spcAft>
             </a:pPr>
             <a:r>
-              <a:rPr sz="1800" b="1" i="0">
-                <a:solidFill>
-                  <a:srgbClr val="4A90D9"/>
-                </a:solidFill>
-                <a:latin typeface="Lato"/>
-              </a:rPr>
-              <a:t>1.  </a:t>
-            </a:r>
-            <a:r>
               <a:rPr sz="1800" b="0" i="0">
                 <a:solidFill>
                   <a:srgbClr val="E0E0E0"/>
                 </a:solidFill>
                 <a:latin typeface="Lato"/>
               </a:rPr>
-              <a:t>Ask Claude to install the GitHub CLI</a:t>
+              <a:t>•  If the app opens in your browser: your entire environment is working</a:t>
             </a:r>
           </a:p>
           <a:p>
             <a:pPr algn="l">
               <a:spcAft>
-                <a:spcPts val="1200"/>
+                <a:spcPts val="1000"/>
               </a:spcAft>
             </a:pPr>
             <a:r>
-              <a:rPr sz="1800" b="1" i="0">
-                <a:solidFill>
-                  <a:srgbClr val="4A90D9"/>
-                </a:solidFill>
-                <a:latin typeface="Lato"/>
-              </a:rPr>
-              <a:t>2.  </a:t>
-            </a:r>
-            <a:r>
               <a:rPr sz="1800" b="0" i="0">
                 <a:solidFill>
                   <a:srgbClr val="E0E0E0"/>
                 </a:solidFill>
                 <a:latin typeface="Lato"/>
               </a:rPr>
-              <a:t>Open a new Warp tab and run `gh auth login`</a:t>
+              <a:t>•  It means Warp is installed, GitHub CLI is ready, SSH is configured, and the repo is cloned</a:t>
             </a:r>
           </a:p>
           <a:p>
             <a:pPr algn="l">
               <a:spcAft>
-                <a:spcPts val="1200"/>
+                <a:spcPts val="1000"/>
               </a:spcAft>
             </a:pPr>
             <a:r>
+              <a:rPr sz="1800" b="0" i="0">
+                <a:solidFill>
+                  <a:srgbClr val="E0E0E0"/>
+                </a:solidFill>
+                <a:latin typeface="Lato"/>
+              </a:rPr>
+              <a:t>•  Screenshot this page or show it to a facilitator — this is your proof you completed Pod 01 setup</a:t>
+            </a:r>
+          </a:p>
+          <a:p>
+            <a:pPr algn="l">
+              <a:spcAft>
+                <a:spcPts val="1000"/>
+              </a:spcAft>
+            </a:pPr>
+            <a:r>
               <a:rPr sz="1800" b="1" i="0">
                 <a:solidFill>
                   <a:srgbClr val="4A90D9"/>
                 </a:solidFill>
                 <a:latin typeface="Lato"/>
               </a:rPr>
-              <a:t>3.  </a:t>
-            </a:r>
-            <a:r>
-              <a:rPr sz="1800" b="0" i="0">
-                <a:solidFill>
-                  <a:srgbClr val="E0E0E0"/>
-                </a:solidFill>
-                <a:latin typeface="Lato"/>
-              </a:rPr>
-              <a:t>Come back to Claude Code and verify the connection</a:t>
+              <a:t>•  You just set up a professional developer environment. Without writing a single line of code.</a:t>
             </a:r>
           </a:p>
         </p:txBody>
@@ -8244,8 +8522,8 @@
         </p:nvSpPr>
         <p:spPr>
           <a:xfrm>
-            <a:off x="731520" y="365760"/>
-            <a:ext cx="10728655" cy="914400"/>
+            <a:off x="914400" y="2560320"/>
+            <a:ext cx="10362895" cy="1371600"/>
           </a:xfrm>
           <a:prstGeom prst="rect">
             <a:avLst/>
@@ -8253,18 +8531,20 @@
           <a:noFill/>
         </p:spPr>
         <p:txBody>
-          <a:bodyPr wrap="square"/>
-          <a:lstStyle/>
-          <a:p>
-            <a:pPr algn="l"/>
-            <a:r>
-              <a:rPr sz="2800" b="1" i="0">
+          <a:bodyPr wrap="square">
+            <a:spAutoFit/>
+          </a:bodyPr>
+          <a:lstStyle/>
+          <a:p>
+            <a:pPr algn="ctr"/>
+            <a:r>
+              <a:rPr sz="3200" b="1" i="0">
                 <a:solidFill>
                   <a:srgbClr val="FFFFFF"/>
                 </a:solidFill>
                 <a:latin typeface="Lato"/>
               </a:rPr>
-              <a:t>Exercise 4: Clone and Explore (5 min)</a:t>
+              <a:t>Hands-On Exercises (30 min)</a:t>
             </a:r>
           </a:p>
         </p:txBody>
@@ -8277,8 +8557,8 @@
         </p:nvSpPr>
         <p:spPr>
           <a:xfrm>
-            <a:off x="5181447" y="1325880"/>
-            <a:ext cx="1828800" cy="54864"/>
+            <a:off x="4724247" y="4114800"/>
+            <a:ext cx="2743200" cy="54864"/>
           </a:xfrm>
           <a:prstGeom prst="rect">
             <a:avLst/>
@@ -8309,102 +8589,6 @@
           <a:lstStyle/>
           <a:p>
             <a:pPr algn="ctr"/>
-          </a:p>
-        </p:txBody>
-      </p:sp>
-      <p:sp>
-        <p:nvSpPr>
-          <p:cNvPr id="4" name="TextBox 3"/>
-          <p:cNvSpPr txBox="1"/>
-          <p:nvPr/>
-        </p:nvSpPr>
-        <p:spPr>
-          <a:xfrm>
-            <a:off x="731520" y="1645920"/>
-            <a:ext cx="10728655" cy="4754880"/>
-          </a:xfrm>
-          <a:prstGeom prst="rect">
-            <a:avLst/>
-          </a:prstGeom>
-          <a:noFill/>
-        </p:spPr>
-        <p:txBody>
-          <a:bodyPr wrap="square"/>
-          <a:lstStyle/>
-          <a:p>
-            <a:pPr algn="l">
-              <a:spcAft>
-                <a:spcPts val="1200"/>
-              </a:spcAft>
-            </a:pPr>
-            <a:r>
-              <a:rPr sz="1800" b="1" i="0">
-                <a:solidFill>
-                  <a:srgbClr val="4A90D9"/>
-                </a:solidFill>
-                <a:latin typeface="Lato"/>
-              </a:rPr>
-              <a:t>1.  </a:t>
-            </a:r>
-            <a:r>
-              <a:rPr sz="1800" b="0" i="0">
-                <a:solidFill>
-                  <a:srgbClr val="E0E0E0"/>
-                </a:solidFill>
-                <a:latin typeface="Lato"/>
-              </a:rPr>
-              <a:t>Clone the learning_pods repo via Claude Code</a:t>
-            </a:r>
-          </a:p>
-          <a:p>
-            <a:pPr algn="l">
-              <a:spcAft>
-                <a:spcPts val="1200"/>
-              </a:spcAft>
-            </a:pPr>
-            <a:r>
-              <a:rPr sz="1800" b="1" i="0">
-                <a:solidFill>
-                  <a:srgbClr val="4A90D9"/>
-                </a:solidFill>
-                <a:latin typeface="Lato"/>
-              </a:rPr>
-              <a:t>2.  </a:t>
-            </a:r>
-            <a:r>
-              <a:rPr sz="1800" b="0" i="0">
-                <a:solidFill>
-                  <a:srgbClr val="E0E0E0"/>
-                </a:solidFill>
-                <a:latin typeface="Lato"/>
-              </a:rPr>
-              <a:t>Open the Pod 01 app (index.html) in your browser</a:t>
-            </a:r>
-          </a:p>
-          <a:p>
-            <a:pPr algn="l">
-              <a:spcAft>
-                <a:spcPts val="1200"/>
-              </a:spcAft>
-            </a:pPr>
-            <a:r>
-              <a:rPr sz="1800" b="1" i="0">
-                <a:solidFill>
-                  <a:srgbClr val="4A90D9"/>
-                </a:solidFill>
-                <a:latin typeface="Lato"/>
-              </a:rPr>
-              <a:t>3.  </a:t>
-            </a:r>
-            <a:r>
-              <a:rPr sz="1800" b="0" i="0">
-                <a:solidFill>
-                  <a:srgbClr val="E0E0E0"/>
-                </a:solidFill>
-                <a:latin typeface="Lato"/>
-              </a:rPr>
-              <a:t>Click through the lecture notes — this is your revision tool</a:t>
-            </a:r>
           </a:p>
         </p:txBody>
       </p:sp>
@@ -8546,8 +8730,8 @@
         </p:nvSpPr>
         <p:spPr>
           <a:xfrm>
-            <a:off x="914400" y="2560320"/>
-            <a:ext cx="10362895" cy="1371600"/>
+            <a:off x="731520" y="365760"/>
+            <a:ext cx="10728655" cy="914400"/>
           </a:xfrm>
           <a:prstGeom prst="rect">
             <a:avLst/>
@@ -8555,20 +8739,18 @@
           <a:noFill/>
         </p:spPr>
         <p:txBody>
-          <a:bodyPr wrap="square">
-            <a:spAutoFit/>
-          </a:bodyPr>
-          <a:lstStyle/>
-          <a:p>
-            <a:pPr algn="ctr"/>
-            <a:r>
-              <a:rPr sz="3200" b="1" i="0">
+          <a:bodyPr wrap="square"/>
+          <a:lstStyle/>
+          <a:p>
+            <a:pPr algn="l"/>
+            <a:r>
+              <a:rPr sz="2800" b="1" i="0">
                 <a:solidFill>
                   <a:srgbClr val="FFFFFF"/>
                 </a:solidFill>
                 <a:latin typeface="Lato"/>
               </a:rPr>
-              <a:t>Key Takeaways</a:t>
+              <a:t>Exercise 1: Set Up Your Workspace (5 min)</a:t>
             </a:r>
           </a:p>
         </p:txBody>
@@ -8581,8 +8763,8 @@
         </p:nvSpPr>
         <p:spPr>
           <a:xfrm>
-            <a:off x="4724247" y="4114800"/>
-            <a:ext cx="2743200" cy="54864"/>
+            <a:off x="5181447" y="1325880"/>
+            <a:ext cx="1828800" cy="54864"/>
           </a:xfrm>
           <a:prstGeom prst="rect">
             <a:avLst/>
@@ -8613,6 +8795,102 @@
           <a:lstStyle/>
           <a:p>
             <a:pPr algn="ctr"/>
+          </a:p>
+        </p:txBody>
+      </p:sp>
+      <p:sp>
+        <p:nvSpPr>
+          <p:cNvPr id="4" name="TextBox 3"/>
+          <p:cNvSpPr txBox="1"/>
+          <p:nvPr/>
+        </p:nvSpPr>
+        <p:spPr>
+          <a:xfrm>
+            <a:off x="731520" y="1645920"/>
+            <a:ext cx="10728655" cy="4754880"/>
+          </a:xfrm>
+          <a:prstGeom prst="rect">
+            <a:avLst/>
+          </a:prstGeom>
+          <a:noFill/>
+        </p:spPr>
+        <p:txBody>
+          <a:bodyPr wrap="square"/>
+          <a:lstStyle/>
+          <a:p>
+            <a:pPr algn="l">
+              <a:spcAft>
+                <a:spcPts val="1200"/>
+              </a:spcAft>
+            </a:pPr>
+            <a:r>
+              <a:rPr sz="1800" b="1" i="0">
+                <a:solidFill>
+                  <a:srgbClr val="4A90D9"/>
+                </a:solidFill>
+                <a:latin typeface="Lato"/>
+              </a:rPr>
+              <a:t>1.  </a:t>
+            </a:r>
+            <a:r>
+              <a:rPr sz="1800" b="0" i="0">
+                <a:solidFill>
+                  <a:srgbClr val="E0E0E0"/>
+                </a:solidFill>
+                <a:latin typeface="Lato"/>
+              </a:rPr>
+              <a:t>Create `~/claude_projects/` if you haven't already</a:t>
+            </a:r>
+          </a:p>
+          <a:p>
+            <a:pPr algn="l">
+              <a:spcAft>
+                <a:spcPts val="1200"/>
+              </a:spcAft>
+            </a:pPr>
+            <a:r>
+              <a:rPr sz="1800" b="1" i="0">
+                <a:solidFill>
+                  <a:srgbClr val="4A90D9"/>
+                </a:solidFill>
+                <a:latin typeface="Lato"/>
+              </a:rPr>
+              <a:t>2.  </a:t>
+            </a:r>
+            <a:r>
+              <a:rPr sz="1800" b="0" i="0">
+                <a:solidFill>
+                  <a:srgbClr val="E0E0E0"/>
+                </a:solidFill>
+                <a:latin typeface="Lato"/>
+              </a:rPr>
+              <a:t>Verify with `pwd` and `ls`</a:t>
+            </a:r>
+          </a:p>
+          <a:p>
+            <a:pPr algn="l">
+              <a:spcAft>
+                <a:spcPts val="1200"/>
+              </a:spcAft>
+            </a:pPr>
+            <a:r>
+              <a:rPr sz="1800" b="1" i="0">
+                <a:solidFill>
+                  <a:srgbClr val="4A90D9"/>
+                </a:solidFill>
+                <a:latin typeface="Lato"/>
+              </a:rPr>
+              <a:t>3.  </a:t>
+            </a:r>
+            <a:r>
+              <a:rPr sz="1800" b="0" i="0">
+                <a:solidFill>
+                  <a:srgbClr val="E0E0E0"/>
+                </a:solidFill>
+                <a:latin typeface="Lato"/>
+              </a:rPr>
+              <a:t>Check it in File Explorer / Finder too — same folder, two views</a:t>
+            </a:r>
           </a:p>
         </p:txBody>
       </p:sp>
@@ -8625,6 +8903,729 @@
 </file>
 
 <file path=ppt/slides/slide41.xml><?xml version="1.0" encoding="utf-8"?>
+<p:sld xmlns:a="http://schemas.openxmlformats.org/drawingml/2006/main" xmlns:p="http://schemas.openxmlformats.org/presentationml/2006/main" xmlns:r="http://schemas.openxmlformats.org/officeDocument/2006/relationships">
+  <p:cSld>
+    <p:bg>
+      <p:bgPr>
+        <a:solidFill>
+          <a:srgbClr val="1A1A2E"/>
+        </a:solidFill>
+        <a:effectLst/>
+      </p:bgPr>
+    </p:bg>
+    <p:spTree>
+      <p:nvGrpSpPr>
+        <p:cNvPr id="1" name=""/>
+        <p:cNvGrpSpPr/>
+        <p:nvPr/>
+      </p:nvGrpSpPr>
+      <p:grpSpPr/>
+      <p:sp>
+        <p:nvSpPr>
+          <p:cNvPr id="2" name="TextBox 1"/>
+          <p:cNvSpPr txBox="1"/>
+          <p:nvPr/>
+        </p:nvSpPr>
+        <p:spPr>
+          <a:xfrm>
+            <a:off x="731520" y="365760"/>
+            <a:ext cx="10728655" cy="914400"/>
+          </a:xfrm>
+          <a:prstGeom prst="rect">
+            <a:avLst/>
+          </a:prstGeom>
+          <a:noFill/>
+        </p:spPr>
+        <p:txBody>
+          <a:bodyPr wrap="square"/>
+          <a:lstStyle/>
+          <a:p>
+            <a:pPr algn="l"/>
+            <a:r>
+              <a:rPr sz="2800" b="1" i="0">
+                <a:solidFill>
+                  <a:srgbClr val="FFFFFF"/>
+                </a:solidFill>
+                <a:latin typeface="Lato"/>
+              </a:rPr>
+              <a:t>Exercise 2: Your First Project (10 min)</a:t>
+            </a:r>
+          </a:p>
+        </p:txBody>
+      </p:sp>
+      <p:sp>
+        <p:nvSpPr>
+          <p:cNvPr id="3" name="Rectangle 2"/>
+          <p:cNvSpPr/>
+          <p:nvPr/>
+        </p:nvSpPr>
+        <p:spPr>
+          <a:xfrm>
+            <a:off x="5181447" y="1325880"/>
+            <a:ext cx="1828800" cy="54864"/>
+          </a:xfrm>
+          <a:prstGeom prst="rect">
+            <a:avLst/>
+          </a:prstGeom>
+          <a:solidFill>
+            <a:srgbClr val="4A90D9"/>
+          </a:solidFill>
+          <a:ln>
+            <a:noFill/>
+          </a:ln>
+        </p:spPr>
+        <p:style>
+          <a:lnRef idx="1">
+            <a:schemeClr val="accent1"/>
+          </a:lnRef>
+          <a:fillRef idx="3">
+            <a:schemeClr val="accent1"/>
+          </a:fillRef>
+          <a:effectRef idx="2">
+            <a:schemeClr val="accent1"/>
+          </a:effectRef>
+          <a:fontRef idx="minor">
+            <a:schemeClr val="lt1"/>
+          </a:fontRef>
+        </p:style>
+        <p:txBody>
+          <a:bodyPr rtlCol="0" anchor="ctr"/>
+          <a:lstStyle/>
+          <a:p>
+            <a:pPr algn="ctr"/>
+          </a:p>
+        </p:txBody>
+      </p:sp>
+      <p:sp>
+        <p:nvSpPr>
+          <p:cNvPr id="4" name="TextBox 3"/>
+          <p:cNvSpPr txBox="1"/>
+          <p:nvPr/>
+        </p:nvSpPr>
+        <p:spPr>
+          <a:xfrm>
+            <a:off x="731520" y="1645920"/>
+            <a:ext cx="10728655" cy="4754880"/>
+          </a:xfrm>
+          <a:prstGeom prst="rect">
+            <a:avLst/>
+          </a:prstGeom>
+          <a:noFill/>
+        </p:spPr>
+        <p:txBody>
+          <a:bodyPr wrap="square"/>
+          <a:lstStyle/>
+          <a:p>
+            <a:pPr algn="l">
+              <a:spcAft>
+                <a:spcPts val="1200"/>
+              </a:spcAft>
+            </a:pPr>
+            <a:r>
+              <a:rPr sz="1800" b="1" i="0">
+                <a:solidFill>
+                  <a:srgbClr val="4A90D9"/>
+                </a:solidFill>
+                <a:latin typeface="Lato"/>
+              </a:rPr>
+              <a:t>1.  </a:t>
+            </a:r>
+            <a:r>
+              <a:rPr sz="1800" b="0" i="0">
+                <a:solidFill>
+                  <a:srgbClr val="E0E0E0"/>
+                </a:solidFill>
+                <a:latin typeface="Lato"/>
+              </a:rPr>
+              <a:t>Create a project folder, start Claude Code</a:t>
+            </a:r>
+          </a:p>
+          <a:p>
+            <a:pPr algn="l">
+              <a:spcAft>
+                <a:spcPts val="1200"/>
+              </a:spcAft>
+            </a:pPr>
+            <a:r>
+              <a:rPr sz="1800" b="1" i="0">
+                <a:solidFill>
+                  <a:srgbClr val="4A90D9"/>
+                </a:solidFill>
+                <a:latin typeface="Lato"/>
+              </a:rPr>
+              <a:t>2.  </a:t>
+            </a:r>
+            <a:r>
+              <a:rPr sz="1800" b="0" i="0">
+                <a:solidFill>
+                  <a:srgbClr val="E0E0E0"/>
+                </a:solidFill>
+                <a:latin typeface="Lato"/>
+              </a:rPr>
+              <a:t>Build an HTML page with your name and Oren branding</a:t>
+            </a:r>
+          </a:p>
+          <a:p>
+            <a:pPr algn="l">
+              <a:spcAft>
+                <a:spcPts val="1200"/>
+              </a:spcAft>
+            </a:pPr>
+            <a:r>
+              <a:rPr sz="1800" b="1" i="0">
+                <a:solidFill>
+                  <a:srgbClr val="4A90D9"/>
+                </a:solidFill>
+                <a:latin typeface="Lato"/>
+              </a:rPr>
+              <a:t>3.  </a:t>
+            </a:r>
+            <a:r>
+              <a:rPr sz="1800" b="0" i="0">
+                <a:solidFill>
+                  <a:srgbClr val="E0E0E0"/>
+                </a:solidFill>
+                <a:latin typeface="Lato"/>
+              </a:rPr>
+              <a:t>Iterate on it — change colors, add content, make it yours</a:t>
+            </a:r>
+          </a:p>
+          <a:p>
+            <a:pPr algn="l">
+              <a:spcAft>
+                <a:spcPts val="1200"/>
+              </a:spcAft>
+            </a:pPr>
+            <a:r>
+              <a:rPr sz="1800" b="1" i="0">
+                <a:solidFill>
+                  <a:srgbClr val="4A90D9"/>
+                </a:solidFill>
+                <a:latin typeface="Lato"/>
+              </a:rPr>
+              <a:t>4.  </a:t>
+            </a:r>
+            <a:r>
+              <a:rPr sz="1800" b="0" i="0">
+                <a:solidFill>
+                  <a:srgbClr val="E0E0E0"/>
+                </a:solidFill>
+                <a:latin typeface="Lato"/>
+              </a:rPr>
+              <a:t>Open it in your browser</a:t>
+            </a:r>
+          </a:p>
+        </p:txBody>
+      </p:sp>
+    </p:spTree>
+  </p:cSld>
+  <p:clrMapOvr>
+    <a:masterClrMapping/>
+  </p:clrMapOvr>
+</p:sld>
+</file>
+
+<file path=ppt/slides/slide42.xml><?xml version="1.0" encoding="utf-8"?>
+<p:sld xmlns:a="http://schemas.openxmlformats.org/drawingml/2006/main" xmlns:p="http://schemas.openxmlformats.org/presentationml/2006/main" xmlns:r="http://schemas.openxmlformats.org/officeDocument/2006/relationships">
+  <p:cSld>
+    <p:bg>
+      <p:bgPr>
+        <a:solidFill>
+          <a:srgbClr val="1A1A2E"/>
+        </a:solidFill>
+        <a:effectLst/>
+      </p:bgPr>
+    </p:bg>
+    <p:spTree>
+      <p:nvGrpSpPr>
+        <p:cNvPr id="1" name=""/>
+        <p:cNvGrpSpPr/>
+        <p:nvPr/>
+      </p:nvGrpSpPr>
+      <p:grpSpPr/>
+      <p:sp>
+        <p:nvSpPr>
+          <p:cNvPr id="2" name="TextBox 1"/>
+          <p:cNvSpPr txBox="1"/>
+          <p:nvPr/>
+        </p:nvSpPr>
+        <p:spPr>
+          <a:xfrm>
+            <a:off x="731520" y="365760"/>
+            <a:ext cx="10728655" cy="914400"/>
+          </a:xfrm>
+          <a:prstGeom prst="rect">
+            <a:avLst/>
+          </a:prstGeom>
+          <a:noFill/>
+        </p:spPr>
+        <p:txBody>
+          <a:bodyPr wrap="square"/>
+          <a:lstStyle/>
+          <a:p>
+            <a:pPr algn="l"/>
+            <a:r>
+              <a:rPr sz="2800" b="1" i="0">
+                <a:solidFill>
+                  <a:srgbClr val="FFFFFF"/>
+                </a:solidFill>
+                <a:latin typeface="Lato"/>
+              </a:rPr>
+              <a:t>Exercise 3: Connect to GitHub (10 min)</a:t>
+            </a:r>
+          </a:p>
+        </p:txBody>
+      </p:sp>
+      <p:sp>
+        <p:nvSpPr>
+          <p:cNvPr id="3" name="Rectangle 2"/>
+          <p:cNvSpPr/>
+          <p:nvPr/>
+        </p:nvSpPr>
+        <p:spPr>
+          <a:xfrm>
+            <a:off x="5181447" y="1325880"/>
+            <a:ext cx="1828800" cy="54864"/>
+          </a:xfrm>
+          <a:prstGeom prst="rect">
+            <a:avLst/>
+          </a:prstGeom>
+          <a:solidFill>
+            <a:srgbClr val="4A90D9"/>
+          </a:solidFill>
+          <a:ln>
+            <a:noFill/>
+          </a:ln>
+        </p:spPr>
+        <p:style>
+          <a:lnRef idx="1">
+            <a:schemeClr val="accent1"/>
+          </a:lnRef>
+          <a:fillRef idx="3">
+            <a:schemeClr val="accent1"/>
+          </a:fillRef>
+          <a:effectRef idx="2">
+            <a:schemeClr val="accent1"/>
+          </a:effectRef>
+          <a:fontRef idx="minor">
+            <a:schemeClr val="lt1"/>
+          </a:fontRef>
+        </p:style>
+        <p:txBody>
+          <a:bodyPr rtlCol="0" anchor="ctr"/>
+          <a:lstStyle/>
+          <a:p>
+            <a:pPr algn="ctr"/>
+          </a:p>
+        </p:txBody>
+      </p:sp>
+      <p:sp>
+        <p:nvSpPr>
+          <p:cNvPr id="4" name="TextBox 3"/>
+          <p:cNvSpPr txBox="1"/>
+          <p:nvPr/>
+        </p:nvSpPr>
+        <p:spPr>
+          <a:xfrm>
+            <a:off x="731520" y="1645920"/>
+            <a:ext cx="10728655" cy="4754880"/>
+          </a:xfrm>
+          <a:prstGeom prst="rect">
+            <a:avLst/>
+          </a:prstGeom>
+          <a:noFill/>
+        </p:spPr>
+        <p:txBody>
+          <a:bodyPr wrap="square"/>
+          <a:lstStyle/>
+          <a:p>
+            <a:pPr algn="l">
+              <a:spcAft>
+                <a:spcPts val="1200"/>
+              </a:spcAft>
+            </a:pPr>
+            <a:r>
+              <a:rPr sz="1800" b="1" i="0">
+                <a:solidFill>
+                  <a:srgbClr val="4A90D9"/>
+                </a:solidFill>
+                <a:latin typeface="Lato"/>
+              </a:rPr>
+              <a:t>1.  </a:t>
+            </a:r>
+            <a:r>
+              <a:rPr sz="1800" b="0" i="0">
+                <a:solidFill>
+                  <a:srgbClr val="E0E0E0"/>
+                </a:solidFill>
+                <a:latin typeface="Lato"/>
+              </a:rPr>
+              <a:t>Ask Claude to install the GitHub CLI</a:t>
+            </a:r>
+          </a:p>
+          <a:p>
+            <a:pPr algn="l">
+              <a:spcAft>
+                <a:spcPts val="1200"/>
+              </a:spcAft>
+            </a:pPr>
+            <a:r>
+              <a:rPr sz="1800" b="1" i="0">
+                <a:solidFill>
+                  <a:srgbClr val="4A90D9"/>
+                </a:solidFill>
+                <a:latin typeface="Lato"/>
+              </a:rPr>
+              <a:t>2.  </a:t>
+            </a:r>
+            <a:r>
+              <a:rPr sz="1800" b="0" i="0">
+                <a:solidFill>
+                  <a:srgbClr val="E0E0E0"/>
+                </a:solidFill>
+                <a:latin typeface="Lato"/>
+              </a:rPr>
+              <a:t>Open a new Warp tab and run `gh auth login`</a:t>
+            </a:r>
+          </a:p>
+          <a:p>
+            <a:pPr algn="l">
+              <a:spcAft>
+                <a:spcPts val="1200"/>
+              </a:spcAft>
+            </a:pPr>
+            <a:r>
+              <a:rPr sz="1800" b="1" i="0">
+                <a:solidFill>
+                  <a:srgbClr val="4A90D9"/>
+                </a:solidFill>
+                <a:latin typeface="Lato"/>
+              </a:rPr>
+              <a:t>3.  </a:t>
+            </a:r>
+            <a:r>
+              <a:rPr sz="1800" b="0" i="0">
+                <a:solidFill>
+                  <a:srgbClr val="E0E0E0"/>
+                </a:solidFill>
+                <a:latin typeface="Lato"/>
+              </a:rPr>
+              <a:t>Come back to Claude Code and verify the connection</a:t>
+            </a:r>
+          </a:p>
+        </p:txBody>
+      </p:sp>
+    </p:spTree>
+  </p:cSld>
+  <p:clrMapOvr>
+    <a:masterClrMapping/>
+  </p:clrMapOvr>
+</p:sld>
+</file>
+
+<file path=ppt/slides/slide43.xml><?xml version="1.0" encoding="utf-8"?>
+<p:sld xmlns:a="http://schemas.openxmlformats.org/drawingml/2006/main" xmlns:p="http://schemas.openxmlformats.org/presentationml/2006/main" xmlns:r="http://schemas.openxmlformats.org/officeDocument/2006/relationships">
+  <p:cSld>
+    <p:bg>
+      <p:bgPr>
+        <a:solidFill>
+          <a:srgbClr val="1A1A2E"/>
+        </a:solidFill>
+        <a:effectLst/>
+      </p:bgPr>
+    </p:bg>
+    <p:spTree>
+      <p:nvGrpSpPr>
+        <p:cNvPr id="1" name=""/>
+        <p:cNvGrpSpPr/>
+        <p:nvPr/>
+      </p:nvGrpSpPr>
+      <p:grpSpPr/>
+      <p:sp>
+        <p:nvSpPr>
+          <p:cNvPr id="2" name="TextBox 1"/>
+          <p:cNvSpPr txBox="1"/>
+          <p:nvPr/>
+        </p:nvSpPr>
+        <p:spPr>
+          <a:xfrm>
+            <a:off x="731520" y="365760"/>
+            <a:ext cx="10728655" cy="914400"/>
+          </a:xfrm>
+          <a:prstGeom prst="rect">
+            <a:avLst/>
+          </a:prstGeom>
+          <a:noFill/>
+        </p:spPr>
+        <p:txBody>
+          <a:bodyPr wrap="square"/>
+          <a:lstStyle/>
+          <a:p>
+            <a:pPr algn="l"/>
+            <a:r>
+              <a:rPr sz="2800" b="1" i="0">
+                <a:solidFill>
+                  <a:srgbClr val="FFFFFF"/>
+                </a:solidFill>
+                <a:latin typeface="Lato"/>
+              </a:rPr>
+              <a:t>Exercise 4: Clone and Explore (5 min)</a:t>
+            </a:r>
+          </a:p>
+        </p:txBody>
+      </p:sp>
+      <p:sp>
+        <p:nvSpPr>
+          <p:cNvPr id="3" name="Rectangle 2"/>
+          <p:cNvSpPr/>
+          <p:nvPr/>
+        </p:nvSpPr>
+        <p:spPr>
+          <a:xfrm>
+            <a:off x="5181447" y="1325880"/>
+            <a:ext cx="1828800" cy="54864"/>
+          </a:xfrm>
+          <a:prstGeom prst="rect">
+            <a:avLst/>
+          </a:prstGeom>
+          <a:solidFill>
+            <a:srgbClr val="4A90D9"/>
+          </a:solidFill>
+          <a:ln>
+            <a:noFill/>
+          </a:ln>
+        </p:spPr>
+        <p:style>
+          <a:lnRef idx="1">
+            <a:schemeClr val="accent1"/>
+          </a:lnRef>
+          <a:fillRef idx="3">
+            <a:schemeClr val="accent1"/>
+          </a:fillRef>
+          <a:effectRef idx="2">
+            <a:schemeClr val="accent1"/>
+          </a:effectRef>
+          <a:fontRef idx="minor">
+            <a:schemeClr val="lt1"/>
+          </a:fontRef>
+        </p:style>
+        <p:txBody>
+          <a:bodyPr rtlCol="0" anchor="ctr"/>
+          <a:lstStyle/>
+          <a:p>
+            <a:pPr algn="ctr"/>
+          </a:p>
+        </p:txBody>
+      </p:sp>
+      <p:sp>
+        <p:nvSpPr>
+          <p:cNvPr id="4" name="TextBox 3"/>
+          <p:cNvSpPr txBox="1"/>
+          <p:nvPr/>
+        </p:nvSpPr>
+        <p:spPr>
+          <a:xfrm>
+            <a:off x="731520" y="1645920"/>
+            <a:ext cx="10728655" cy="4754880"/>
+          </a:xfrm>
+          <a:prstGeom prst="rect">
+            <a:avLst/>
+          </a:prstGeom>
+          <a:noFill/>
+        </p:spPr>
+        <p:txBody>
+          <a:bodyPr wrap="square"/>
+          <a:lstStyle/>
+          <a:p>
+            <a:pPr algn="l">
+              <a:spcAft>
+                <a:spcPts val="1200"/>
+              </a:spcAft>
+            </a:pPr>
+            <a:r>
+              <a:rPr sz="1800" b="1" i="0">
+                <a:solidFill>
+                  <a:srgbClr val="4A90D9"/>
+                </a:solidFill>
+                <a:latin typeface="Lato"/>
+              </a:rPr>
+              <a:t>1.  </a:t>
+            </a:r>
+            <a:r>
+              <a:rPr sz="1800" b="0" i="0">
+                <a:solidFill>
+                  <a:srgbClr val="E0E0E0"/>
+                </a:solidFill>
+                <a:latin typeface="Lato"/>
+              </a:rPr>
+              <a:t>Clone the learning_pods repo via Claude Code</a:t>
+            </a:r>
+          </a:p>
+          <a:p>
+            <a:pPr algn="l">
+              <a:spcAft>
+                <a:spcPts val="1200"/>
+              </a:spcAft>
+            </a:pPr>
+            <a:r>
+              <a:rPr sz="1800" b="1" i="0">
+                <a:solidFill>
+                  <a:srgbClr val="4A90D9"/>
+                </a:solidFill>
+                <a:latin typeface="Lato"/>
+              </a:rPr>
+              <a:t>2.  </a:t>
+            </a:r>
+            <a:r>
+              <a:rPr sz="1800" b="0" i="0">
+                <a:solidFill>
+                  <a:srgbClr val="E0E0E0"/>
+                </a:solidFill>
+                <a:latin typeface="Lato"/>
+              </a:rPr>
+              <a:t>Open the Pod 01 app (index.html) in your browser</a:t>
+            </a:r>
+          </a:p>
+          <a:p>
+            <a:pPr algn="l">
+              <a:spcAft>
+                <a:spcPts val="1200"/>
+              </a:spcAft>
+            </a:pPr>
+            <a:r>
+              <a:rPr sz="1800" b="1" i="0">
+                <a:solidFill>
+                  <a:srgbClr val="4A90D9"/>
+                </a:solidFill>
+                <a:latin typeface="Lato"/>
+              </a:rPr>
+              <a:t>3.  </a:t>
+            </a:r>
+            <a:r>
+              <a:rPr sz="1800" b="0" i="0">
+                <a:solidFill>
+                  <a:srgbClr val="E0E0E0"/>
+                </a:solidFill>
+                <a:latin typeface="Lato"/>
+              </a:rPr>
+              <a:t>Click through the lecture notes — this is your revision tool</a:t>
+            </a:r>
+          </a:p>
+        </p:txBody>
+      </p:sp>
+    </p:spTree>
+  </p:cSld>
+  <p:clrMapOvr>
+    <a:masterClrMapping/>
+  </p:clrMapOvr>
+</p:sld>
+</file>
+
+<file path=ppt/slides/slide44.xml><?xml version="1.0" encoding="utf-8"?>
+<p:sld xmlns:a="http://schemas.openxmlformats.org/drawingml/2006/main" xmlns:p="http://schemas.openxmlformats.org/presentationml/2006/main" xmlns:r="http://schemas.openxmlformats.org/officeDocument/2006/relationships">
+  <p:cSld>
+    <p:bg>
+      <p:bgPr>
+        <a:solidFill>
+          <a:srgbClr val="1A1A2E"/>
+        </a:solidFill>
+        <a:effectLst/>
+      </p:bgPr>
+    </p:bg>
+    <p:spTree>
+      <p:nvGrpSpPr>
+        <p:cNvPr id="1" name=""/>
+        <p:cNvGrpSpPr/>
+        <p:nvPr/>
+      </p:nvGrpSpPr>
+      <p:grpSpPr/>
+      <p:sp>
+        <p:nvSpPr>
+          <p:cNvPr id="2" name="TextBox 1"/>
+          <p:cNvSpPr txBox="1"/>
+          <p:nvPr/>
+        </p:nvSpPr>
+        <p:spPr>
+          <a:xfrm>
+            <a:off x="914400" y="2560320"/>
+            <a:ext cx="10362895" cy="1371600"/>
+          </a:xfrm>
+          <a:prstGeom prst="rect">
+            <a:avLst/>
+          </a:prstGeom>
+          <a:noFill/>
+        </p:spPr>
+        <p:txBody>
+          <a:bodyPr wrap="square">
+            <a:spAutoFit/>
+          </a:bodyPr>
+          <a:lstStyle/>
+          <a:p>
+            <a:pPr algn="ctr"/>
+            <a:r>
+              <a:rPr sz="3200" b="1" i="0">
+                <a:solidFill>
+                  <a:srgbClr val="FFFFFF"/>
+                </a:solidFill>
+                <a:latin typeface="Lato"/>
+              </a:rPr>
+              <a:t>Key Takeaways</a:t>
+            </a:r>
+          </a:p>
+        </p:txBody>
+      </p:sp>
+      <p:sp>
+        <p:nvSpPr>
+          <p:cNvPr id="3" name="Rectangle 2"/>
+          <p:cNvSpPr/>
+          <p:nvPr/>
+        </p:nvSpPr>
+        <p:spPr>
+          <a:xfrm>
+            <a:off x="4724247" y="4114800"/>
+            <a:ext cx="2743200" cy="54864"/>
+          </a:xfrm>
+          <a:prstGeom prst="rect">
+            <a:avLst/>
+          </a:prstGeom>
+          <a:solidFill>
+            <a:srgbClr val="4A90D9"/>
+          </a:solidFill>
+          <a:ln>
+            <a:noFill/>
+          </a:ln>
+        </p:spPr>
+        <p:style>
+          <a:lnRef idx="1">
+            <a:schemeClr val="accent1"/>
+          </a:lnRef>
+          <a:fillRef idx="3">
+            <a:schemeClr val="accent1"/>
+          </a:fillRef>
+          <a:effectRef idx="2">
+            <a:schemeClr val="accent1"/>
+          </a:effectRef>
+          <a:fontRef idx="minor">
+            <a:schemeClr val="lt1"/>
+          </a:fontRef>
+        </p:style>
+        <p:txBody>
+          <a:bodyPr rtlCol="0" anchor="ctr"/>
+          <a:lstStyle/>
+          <a:p>
+            <a:pPr algn="ctr"/>
+          </a:p>
+        </p:txBody>
+      </p:sp>
+    </p:spTree>
+  </p:cSld>
+  <p:clrMapOvr>
+    <a:masterClrMapping/>
+  </p:clrMapOvr>
+</p:sld>
+</file>
+
+<file path=ppt/slides/slide45.xml><?xml version="1.0" encoding="utf-8"?>
 <p:sld xmlns:a="http://schemas.openxmlformats.org/drawingml/2006/main" xmlns:p="http://schemas.openxmlformats.org/presentationml/2006/main" xmlns:r="http://schemas.openxmlformats.org/officeDocument/2006/relationships">
   <p:cSld>
     <p:bg>

</xml_diff>